<commit_message>
Add bar under title of sections
</commit_message>
<xml_diff>
--- a/cheatsheets/sentiment-classifier-cheatsheet.pptx
+++ b/cheatsheets/sentiment-classifier-cheatsheet.pptx
@@ -8,7 +8,7 @@
     <p:notesMasterId r:id="rId3"/>
   </p:notesMasterIdLst>
   <p:sldIdLst>
-    <p:sldId id="265" r:id="rId2"/>
+    <p:sldId id="266" r:id="rId2"/>
   </p:sldIdLst>
   <p:sldSz cx="13970000" cy="10795000"/>
   <p:notesSz cx="6858000" cy="9144000"/>
@@ -740,7 +740,7 @@
         <p:cNvPr id="1" name="Shape 208">
           <a:extLst>
             <a:ext uri="{FF2B5EF4-FFF2-40B4-BE49-F238E27FC236}">
-              <a16:creationId xmlns:a16="http://schemas.microsoft.com/office/drawing/2014/main" id="{BF9DE98F-B322-9C28-ABCC-E5BA705734EB}"/>
+              <a16:creationId xmlns:a16="http://schemas.microsoft.com/office/drawing/2014/main" id="{D3B23A6B-A1DB-7A80-F2B2-21D1B3D5D2F7}"/>
             </a:ext>
           </a:extLst>
         </p:cNvPr>
@@ -760,7 +760,7 @@
           <p:cNvPr id="209" name="Google Shape;209;g3d6bdaf8f06_0_46:notes">
             <a:extLst>
               <a:ext uri="{FF2B5EF4-FFF2-40B4-BE49-F238E27FC236}">
-                <a16:creationId xmlns:a16="http://schemas.microsoft.com/office/drawing/2014/main" id="{2079FAC7-34A1-DAED-E191-34B63207D028}"/>
+                <a16:creationId xmlns:a16="http://schemas.microsoft.com/office/drawing/2014/main" id="{A8A0997C-2B91-F470-6D5F-5E5368171C77}"/>
               </a:ext>
             </a:extLst>
           </p:cNvPr>
@@ -807,7 +807,7 @@
           <p:cNvPr id="210" name="Google Shape;210;g3d6bdaf8f06_0_46:notes">
             <a:extLst>
               <a:ext uri="{FF2B5EF4-FFF2-40B4-BE49-F238E27FC236}">
-                <a16:creationId xmlns:a16="http://schemas.microsoft.com/office/drawing/2014/main" id="{657B4C1E-2A48-AF46-A967-3087636E408B}"/>
+                <a16:creationId xmlns:a16="http://schemas.microsoft.com/office/drawing/2014/main" id="{3335F671-DCAC-23EB-46A0-D4D36B53BA14}"/>
               </a:ext>
             </a:extLst>
           </p:cNvPr>
@@ -833,7 +833,7 @@
           </a:bodyPr>
           <a:lstStyle/>
           <a:p>
-            <a:pPr marL="158750" lvl="0" indent="0" algn="l" rtl="0">
+            <a:pPr marL="457200" lvl="0" indent="-298450" algn="l" rtl="0">
               <a:spcBef>
                 <a:spcPts val="0"/>
               </a:spcBef>
@@ -841,7 +841,7 @@
                 <a:spcPts val="0"/>
               </a:spcAft>
               <a:buSzPts val="1100"/>
-              <a:buNone/>
+              <a:buChar char="-"/>
             </a:pPr>
             <a:endParaRPr dirty="0"/>
           </a:p>
@@ -850,7 +850,7 @@
     </p:spTree>
     <p:extLst>
       <p:ext uri="{BB962C8B-B14F-4D97-AF65-F5344CB8AC3E}">
-        <p14:creationId xmlns:p14="http://schemas.microsoft.com/office/powerpoint/2010/main" val="3132621710"/>
+        <p14:creationId xmlns:p14="http://schemas.microsoft.com/office/powerpoint/2010/main" val="662489742"/>
       </p:ext>
     </p:extLst>
   </p:cSld>
@@ -5521,7 +5521,7 @@
         <p:cNvPr id="1" name="Shape 211">
           <a:extLst>
             <a:ext uri="{FF2B5EF4-FFF2-40B4-BE49-F238E27FC236}">
-              <a16:creationId xmlns:a16="http://schemas.microsoft.com/office/drawing/2014/main" id="{EB458DBE-69C5-2ACF-497E-2369E742B504}"/>
+              <a16:creationId xmlns:a16="http://schemas.microsoft.com/office/drawing/2014/main" id="{9BE09234-A7A9-ECC2-4F0F-B1D6170A559A}"/>
             </a:ext>
           </a:extLst>
         </p:cNvPr>
@@ -5541,7 +5541,7 @@
           <p:cNvPr id="2" name="Image" descr="Image">
             <a:extLst>
               <a:ext uri="{FF2B5EF4-FFF2-40B4-BE49-F238E27FC236}">
-                <a16:creationId xmlns:a16="http://schemas.microsoft.com/office/drawing/2014/main" id="{4A74CFD9-A17B-FAF1-9062-C130647A07E0}"/>
+                <a16:creationId xmlns:a16="http://schemas.microsoft.com/office/drawing/2014/main" id="{DC354BA0-4832-CE7C-2CE1-D891E125B448}"/>
               </a:ext>
             </a:extLst>
           </p:cNvPr>
@@ -5574,7 +5574,7 @@
           <p:cNvPr id="3" name="Picture 2" descr="A picture containing text&#10;&#10;Description automatically generated">
             <a:extLst>
               <a:ext uri="{FF2B5EF4-FFF2-40B4-BE49-F238E27FC236}">
-                <a16:creationId xmlns:a16="http://schemas.microsoft.com/office/drawing/2014/main" id="{6B7F8AAC-F75E-3205-3592-F7C261488005}"/>
+                <a16:creationId xmlns:a16="http://schemas.microsoft.com/office/drawing/2014/main" id="{46BF77F5-CF07-313F-6E8C-09D771422DE3}"/>
               </a:ext>
             </a:extLst>
           </p:cNvPr>
@@ -5610,7 +5610,7 @@
           <p:cNvPr id="216" name="Google Shape;216;p18">
             <a:extLst>
               <a:ext uri="{FF2B5EF4-FFF2-40B4-BE49-F238E27FC236}">
-                <a16:creationId xmlns:a16="http://schemas.microsoft.com/office/drawing/2014/main" id="{323DA3D9-23E3-A6C7-3436-E70904C5CC5A}"/>
+                <a16:creationId xmlns:a16="http://schemas.microsoft.com/office/drawing/2014/main" id="{3A938C08-2907-E64B-65F6-C13C39460C82}"/>
               </a:ext>
             </a:extLst>
           </p:cNvPr>
@@ -5627,7 +5627,7 @@
         </p:blipFill>
         <p:spPr>
           <a:xfrm>
-            <a:off x="210203" y="8408251"/>
+            <a:off x="210203" y="8615102"/>
             <a:ext cx="3874636" cy="1607085"/>
           </a:xfrm>
           <a:prstGeom prst="rect">
@@ -5644,7 +5644,7 @@
           <p:cNvPr id="217" name="Google Shape;217;p18">
             <a:extLst>
               <a:ext uri="{FF2B5EF4-FFF2-40B4-BE49-F238E27FC236}">
-                <a16:creationId xmlns:a16="http://schemas.microsoft.com/office/drawing/2014/main" id="{5398C4A8-5205-B969-F716-F56FD20E761A}"/>
+                <a16:creationId xmlns:a16="http://schemas.microsoft.com/office/drawing/2014/main" id="{04B86DA8-19C9-AE3B-1126-F26770F30491}"/>
               </a:ext>
             </a:extLst>
           </p:cNvPr>
@@ -5661,7 +5661,7 @@
         </p:blipFill>
         <p:spPr>
           <a:xfrm>
-            <a:off x="234403" y="2802519"/>
+            <a:off x="234403" y="3009370"/>
             <a:ext cx="3830026" cy="4983643"/>
           </a:xfrm>
           <a:prstGeom prst="rect">
@@ -5678,7 +5678,7 @@
           <p:cNvPr id="220" name="Google Shape;220;p18">
             <a:extLst>
               <a:ext uri="{FF2B5EF4-FFF2-40B4-BE49-F238E27FC236}">
-                <a16:creationId xmlns:a16="http://schemas.microsoft.com/office/drawing/2014/main" id="{1BCCE602-BC70-1880-3AD9-E77E23D688D9}"/>
+                <a16:creationId xmlns:a16="http://schemas.microsoft.com/office/drawing/2014/main" id="{06D5D828-0841-470D-D032-0DCF08495D99}"/>
               </a:ext>
             </a:extLst>
           </p:cNvPr>
@@ -5687,7 +5687,7 @@
         </p:nvSpPr>
         <p:spPr>
           <a:xfrm>
-            <a:off x="9398473" y="2540773"/>
+            <a:off x="9398473" y="2747624"/>
             <a:ext cx="4001250" cy="1037469"/>
           </a:xfrm>
           <a:prstGeom prst="rect">
@@ -5724,7 +5724,7 @@
           <p:cNvPr id="221" name="Google Shape;221;p18">
             <a:extLst>
               <a:ext uri="{FF2B5EF4-FFF2-40B4-BE49-F238E27FC236}">
-                <a16:creationId xmlns:a16="http://schemas.microsoft.com/office/drawing/2014/main" id="{DD827EEA-1A12-5249-D42A-A6DF17766795}"/>
+                <a16:creationId xmlns:a16="http://schemas.microsoft.com/office/drawing/2014/main" id="{31E64EFF-D7B9-76D2-5D2C-07818777D302}"/>
               </a:ext>
             </a:extLst>
           </p:cNvPr>
@@ -5733,7 +5733,7 @@
         </p:nvSpPr>
         <p:spPr>
           <a:xfrm>
-            <a:off x="274320" y="1143413"/>
+            <a:off x="274320" y="1350264"/>
             <a:ext cx="1303481" cy="517458"/>
           </a:xfrm>
           <a:prstGeom prst="rect">
@@ -5779,7 +5779,7 @@
           <p:cNvPr id="222" name="Google Shape;222;p18">
             <a:extLst>
               <a:ext uri="{FF2B5EF4-FFF2-40B4-BE49-F238E27FC236}">
-                <a16:creationId xmlns:a16="http://schemas.microsoft.com/office/drawing/2014/main" id="{5D0CCC26-107D-2B08-2A13-2F754B30CF8A}"/>
+                <a16:creationId xmlns:a16="http://schemas.microsoft.com/office/drawing/2014/main" id="{3A8164A0-BFCB-2FD8-719D-6AF7ECEB8B22}"/>
               </a:ext>
             </a:extLst>
           </p:cNvPr>
@@ -5788,7 +5788,7 @@
         </p:nvSpPr>
         <p:spPr>
           <a:xfrm>
-            <a:off x="4293309" y="1143000"/>
+            <a:off x="4293309" y="1349851"/>
             <a:ext cx="3525958" cy="540833"/>
           </a:xfrm>
           <a:prstGeom prst="rect">
@@ -5834,7 +5834,7 @@
           <p:cNvPr id="223" name="Google Shape;223;p18">
             <a:extLst>
               <a:ext uri="{FF2B5EF4-FFF2-40B4-BE49-F238E27FC236}">
-                <a16:creationId xmlns:a16="http://schemas.microsoft.com/office/drawing/2014/main" id="{85D6570D-B5DF-BC04-6F53-0C3A42FCC662}"/>
+                <a16:creationId xmlns:a16="http://schemas.microsoft.com/office/drawing/2014/main" id="{0BCB5E6E-18BD-027E-6CF0-A0559A98EBC1}"/>
               </a:ext>
             </a:extLst>
           </p:cNvPr>
@@ -5843,7 +5843,7 @@
         </p:nvSpPr>
         <p:spPr>
           <a:xfrm>
-            <a:off x="9319813" y="3528925"/>
+            <a:off x="9319813" y="3735776"/>
             <a:ext cx="3202999" cy="540833"/>
           </a:xfrm>
           <a:prstGeom prst="rect">
@@ -5889,7 +5889,7 @@
           <p:cNvPr id="224" name="Google Shape;224;p18">
             <a:extLst>
               <a:ext uri="{FF2B5EF4-FFF2-40B4-BE49-F238E27FC236}">
-                <a16:creationId xmlns:a16="http://schemas.microsoft.com/office/drawing/2014/main" id="{B8D02676-F2CA-E397-D6A5-7C5F5FA65D4B}"/>
+                <a16:creationId xmlns:a16="http://schemas.microsoft.com/office/drawing/2014/main" id="{E008AD1E-09E2-01CE-2BA3-4B2A27652F7E}"/>
               </a:ext>
             </a:extLst>
           </p:cNvPr>
@@ -5898,7 +5898,7 @@
         </p:nvSpPr>
         <p:spPr>
           <a:xfrm>
-            <a:off x="274320" y="2718127"/>
+            <a:off x="274320" y="2924978"/>
             <a:ext cx="3461898" cy="540833"/>
           </a:xfrm>
           <a:prstGeom prst="rect">
@@ -5944,7 +5944,7 @@
           <p:cNvPr id="225" name="Google Shape;225;p18">
             <a:extLst>
               <a:ext uri="{FF2B5EF4-FFF2-40B4-BE49-F238E27FC236}">
-                <a16:creationId xmlns:a16="http://schemas.microsoft.com/office/drawing/2014/main" id="{C33BC7D8-60D4-E54D-2E8D-FA597846BBE1}"/>
+                <a16:creationId xmlns:a16="http://schemas.microsoft.com/office/drawing/2014/main" id="{868B08B6-B6AF-D740-8E8B-805C990DE0B6}"/>
               </a:ext>
             </a:extLst>
           </p:cNvPr>
@@ -5953,7 +5953,7 @@
         </p:nvSpPr>
         <p:spPr>
           <a:xfrm>
-            <a:off x="9317736" y="1143000"/>
+            <a:off x="9317736" y="1349851"/>
             <a:ext cx="3525958" cy="540833"/>
           </a:xfrm>
           <a:prstGeom prst="rect">
@@ -6004,7 +6004,7 @@
           <p:cNvPr id="226" name="Google Shape;226;p18">
             <a:extLst>
               <a:ext uri="{FF2B5EF4-FFF2-40B4-BE49-F238E27FC236}">
-                <a16:creationId xmlns:a16="http://schemas.microsoft.com/office/drawing/2014/main" id="{AC0D0BA9-470F-1211-A3D2-C43E2B979600}"/>
+                <a16:creationId xmlns:a16="http://schemas.microsoft.com/office/drawing/2014/main" id="{42AADD63-DDA3-D4B4-5C37-74E86F33C492}"/>
               </a:ext>
             </a:extLst>
           </p:cNvPr>
@@ -6013,7 +6013,7 @@
         </p:nvSpPr>
         <p:spPr>
           <a:xfrm>
-            <a:off x="9419498" y="2613517"/>
+            <a:off x="9419498" y="2820368"/>
             <a:ext cx="3795917" cy="928413"/>
           </a:xfrm>
           <a:prstGeom prst="rect">
@@ -6105,7 +6105,7 @@
           <p:cNvPr id="227" name="Google Shape;227;p18">
             <a:extLst>
               <a:ext uri="{FF2B5EF4-FFF2-40B4-BE49-F238E27FC236}">
-                <a16:creationId xmlns:a16="http://schemas.microsoft.com/office/drawing/2014/main" id="{E2C148EA-3A57-2759-F506-371F78985848}"/>
+                <a16:creationId xmlns:a16="http://schemas.microsoft.com/office/drawing/2014/main" id="{312D8081-3435-5E6A-7284-E81CF41E7030}"/>
               </a:ext>
             </a:extLst>
           </p:cNvPr>
@@ -6114,7 +6114,7 @@
         </p:nvSpPr>
         <p:spPr>
           <a:xfrm>
-            <a:off x="9324372" y="1619545"/>
+            <a:off x="9324372" y="1826396"/>
             <a:ext cx="3825854" cy="836080"/>
           </a:xfrm>
           <a:prstGeom prst="rect">
@@ -6160,7 +6160,7 @@
           <p:cNvPr id="228" name="Google Shape;228;p18">
             <a:extLst>
               <a:ext uri="{FF2B5EF4-FFF2-40B4-BE49-F238E27FC236}">
-                <a16:creationId xmlns:a16="http://schemas.microsoft.com/office/drawing/2014/main" id="{2102D2A6-BE3E-33B4-37A2-A9A3BE5A5CE2}"/>
+                <a16:creationId xmlns:a16="http://schemas.microsoft.com/office/drawing/2014/main" id="{60CC3179-20FF-4381-B9D2-C2E457D71559}"/>
               </a:ext>
             </a:extLst>
           </p:cNvPr>
@@ -6169,7 +6169,7 @@
         </p:nvSpPr>
         <p:spPr>
           <a:xfrm>
-            <a:off x="253301" y="1520334"/>
+            <a:off x="253301" y="1727185"/>
             <a:ext cx="4092520" cy="1205412"/>
           </a:xfrm>
           <a:prstGeom prst="rect">
@@ -6266,7 +6266,7 @@
           <p:cNvPr id="229" name="Google Shape;229;p18">
             <a:extLst>
               <a:ext uri="{FF2B5EF4-FFF2-40B4-BE49-F238E27FC236}">
-                <a16:creationId xmlns:a16="http://schemas.microsoft.com/office/drawing/2014/main" id="{0BC91131-6C3F-2753-C82A-FACE0BD6E102}"/>
+                <a16:creationId xmlns:a16="http://schemas.microsoft.com/office/drawing/2014/main" id="{3F7AA3B3-1EDA-7CF0-12EC-345A7F84A588}"/>
               </a:ext>
             </a:extLst>
           </p:cNvPr>
@@ -6275,7 +6275,7 @@
         </p:nvSpPr>
         <p:spPr>
           <a:xfrm>
-            <a:off x="287688" y="3140376"/>
+            <a:off x="287688" y="3347227"/>
             <a:ext cx="3813792" cy="836080"/>
           </a:xfrm>
           <a:prstGeom prst="rect">
@@ -6321,7 +6321,7 @@
           <p:cNvPr id="230" name="Google Shape;230;p18">
             <a:extLst>
               <a:ext uri="{FF2B5EF4-FFF2-40B4-BE49-F238E27FC236}">
-                <a16:creationId xmlns:a16="http://schemas.microsoft.com/office/drawing/2014/main" id="{A0F68A24-5CA3-009F-1B62-04FBCC237148}"/>
+                <a16:creationId xmlns:a16="http://schemas.microsoft.com/office/drawing/2014/main" id="{9DB364D9-7D40-E8B6-489E-C27E82C36F87}"/>
               </a:ext>
             </a:extLst>
           </p:cNvPr>
@@ -6330,7 +6330,7 @@
         </p:nvSpPr>
         <p:spPr>
           <a:xfrm>
-            <a:off x="4270098" y="1677223"/>
+            <a:off x="4270400" y="1833020"/>
             <a:ext cx="4765944" cy="836080"/>
           </a:xfrm>
           <a:prstGeom prst="rect">
@@ -6376,7 +6376,7 @@
           <p:cNvPr id="231" name="Google Shape;231;p18">
             <a:extLst>
               <a:ext uri="{FF2B5EF4-FFF2-40B4-BE49-F238E27FC236}">
-                <a16:creationId xmlns:a16="http://schemas.microsoft.com/office/drawing/2014/main" id="{3059CB30-7FD2-408B-C355-CCF9B3F1D3D3}"/>
+                <a16:creationId xmlns:a16="http://schemas.microsoft.com/office/drawing/2014/main" id="{38F426C3-0C87-2259-EE8A-5C096AD870B1}"/>
               </a:ext>
             </a:extLst>
           </p:cNvPr>
@@ -6385,7 +6385,7 @@
         </p:nvSpPr>
         <p:spPr>
           <a:xfrm>
-            <a:off x="4315289" y="7687879"/>
+            <a:off x="4315289" y="7894730"/>
             <a:ext cx="5498559" cy="2128741"/>
           </a:xfrm>
           <a:prstGeom prst="rect">
@@ -6660,7 +6660,7 @@
           <p:cNvPr id="232" name="Google Shape;232;p18">
             <a:extLst>
               <a:ext uri="{FF2B5EF4-FFF2-40B4-BE49-F238E27FC236}">
-                <a16:creationId xmlns:a16="http://schemas.microsoft.com/office/drawing/2014/main" id="{FE901E42-271C-5804-A768-F91928FF1359}"/>
+                <a16:creationId xmlns:a16="http://schemas.microsoft.com/office/drawing/2014/main" id="{D437CB19-E18B-73E0-3BB7-D30DA2E122D7}"/>
               </a:ext>
             </a:extLst>
           </p:cNvPr>
@@ -6669,7 +6669,7 @@
         </p:nvSpPr>
         <p:spPr>
           <a:xfrm>
-            <a:off x="9352482" y="4045627"/>
+            <a:off x="9352482" y="4252478"/>
             <a:ext cx="4674907" cy="1205412"/>
           </a:xfrm>
           <a:prstGeom prst="rect">
@@ -6715,7 +6715,7 @@
           <p:cNvPr id="233" name="Google Shape;233;p18">
             <a:extLst>
               <a:ext uri="{FF2B5EF4-FFF2-40B4-BE49-F238E27FC236}">
-                <a16:creationId xmlns:a16="http://schemas.microsoft.com/office/drawing/2014/main" id="{A4E78F5D-2CD0-78A4-F08A-B11C68C08568}"/>
+                <a16:creationId xmlns:a16="http://schemas.microsoft.com/office/drawing/2014/main" id="{FDD0A973-F074-6D3A-3CB6-E0B632F22C75}"/>
               </a:ext>
             </a:extLst>
           </p:cNvPr>
@@ -6811,7 +6811,7 @@
           <p:cNvPr id="234" name="Google Shape;234;p18">
             <a:extLst>
               <a:ext uri="{FF2B5EF4-FFF2-40B4-BE49-F238E27FC236}">
-                <a16:creationId xmlns:a16="http://schemas.microsoft.com/office/drawing/2014/main" id="{9B16D1C1-1B2D-3BBC-C438-2C342FD21A39}"/>
+                <a16:creationId xmlns:a16="http://schemas.microsoft.com/office/drawing/2014/main" id="{A1C5A158-7B6D-3206-2523-0B61BB0FA7A6}"/>
               </a:ext>
             </a:extLst>
           </p:cNvPr>
@@ -6820,7 +6820,7 @@
         </p:nvCxnSpPr>
         <p:spPr>
           <a:xfrm>
-            <a:off x="2225439" y="10286909"/>
+            <a:off x="2225439" y="10493760"/>
             <a:ext cx="11481250" cy="9167"/>
           </a:xfrm>
           <a:prstGeom prst="straightConnector1">
@@ -6843,7 +6843,7 @@
           <p:cNvPr id="235" name="Google Shape;235;p18">
             <a:extLst>
               <a:ext uri="{FF2B5EF4-FFF2-40B4-BE49-F238E27FC236}">
-                <a16:creationId xmlns:a16="http://schemas.microsoft.com/office/drawing/2014/main" id="{E871E3B2-6D10-A7C2-FBD0-A083F52FD753}"/>
+                <a16:creationId xmlns:a16="http://schemas.microsoft.com/office/drawing/2014/main" id="{C6B16F93-BDF7-5FE1-7DA9-BA7CB6E63F54}"/>
               </a:ext>
             </a:extLst>
           </p:cNvPr>
@@ -6852,7 +6852,7 @@
         </p:nvSpPr>
         <p:spPr>
           <a:xfrm>
-            <a:off x="404387" y="3898220"/>
+            <a:off x="404387" y="4105071"/>
             <a:ext cx="3566750" cy="3780550"/>
           </a:xfrm>
           <a:prstGeom prst="rect">
@@ -6887,7 +6887,7 @@
           <p:cNvPr id="236" name="Google Shape;236;p18">
             <a:extLst>
               <a:ext uri="{FF2B5EF4-FFF2-40B4-BE49-F238E27FC236}">
-                <a16:creationId xmlns:a16="http://schemas.microsoft.com/office/drawing/2014/main" id="{33C9CF32-9715-4F1C-883D-BA28F47C68F8}"/>
+                <a16:creationId xmlns:a16="http://schemas.microsoft.com/office/drawing/2014/main" id="{1DDE476D-F5CA-25E1-14A5-29AB677ED248}"/>
               </a:ext>
             </a:extLst>
           </p:cNvPr>
@@ -6951,7 +6951,7 @@
           <p:cNvPr id="237" name="Google Shape;237;p18">
             <a:extLst>
               <a:ext uri="{FF2B5EF4-FFF2-40B4-BE49-F238E27FC236}">
-                <a16:creationId xmlns:a16="http://schemas.microsoft.com/office/drawing/2014/main" id="{FC2C1D2F-043F-1E03-3AB3-19DDFF61C11B}"/>
+                <a16:creationId xmlns:a16="http://schemas.microsoft.com/office/drawing/2014/main" id="{9F16129D-974D-D02B-EA33-07AA7011BDE2}"/>
               </a:ext>
             </a:extLst>
           </p:cNvPr>
@@ -6960,8 +6960,8 @@
         </p:nvSpPr>
         <p:spPr>
           <a:xfrm>
-            <a:off x="6644897" y="10244241"/>
-            <a:ext cx="7325103" cy="497526"/>
+            <a:off x="6559733" y="10369856"/>
+            <a:ext cx="7343934" cy="497526"/>
           </a:xfrm>
           <a:prstGeom prst="rect">
             <a:avLst/>
@@ -7029,7 +7029,7 @@
             <a:r>
               <a:rPr lang="en" sz="1000" dirty="0">
                 <a:solidFill>
-                  <a:srgbClr val="4C4C4C"/>
+                  <a:schemeClr val="bg2"/>
                 </a:solidFill>
                 <a:latin typeface="Source Sans 3"/>
                 <a:ea typeface="Source Sans 3"/>
@@ -7040,7 +7040,7 @@
             </a:r>
             <a:endParaRPr sz="1000" dirty="0">
               <a:solidFill>
-                <a:srgbClr val="4C4C4C"/>
+                <a:schemeClr val="bg2"/>
               </a:solidFill>
               <a:latin typeface="Source Sans 3"/>
               <a:ea typeface="Source Sans 3"/>
@@ -7055,7 +7055,7 @@
           <p:cNvPr id="238" name="Google Shape;238;p18">
             <a:extLst>
               <a:ext uri="{FF2B5EF4-FFF2-40B4-BE49-F238E27FC236}">
-                <a16:creationId xmlns:a16="http://schemas.microsoft.com/office/drawing/2014/main" id="{652E21B7-70BE-F1CB-B082-57472A3475E2}"/>
+                <a16:creationId xmlns:a16="http://schemas.microsoft.com/office/drawing/2014/main" id="{9B1615CA-6B20-61F0-7477-94F5E234065E}"/>
               </a:ext>
             </a:extLst>
           </p:cNvPr>
@@ -7064,7 +7064,7 @@
         </p:nvSpPr>
         <p:spPr>
           <a:xfrm>
-            <a:off x="411063" y="4033487"/>
+            <a:off x="411063" y="4240338"/>
             <a:ext cx="3373792" cy="3667624"/>
           </a:xfrm>
           <a:prstGeom prst="rect">
@@ -7510,7 +7510,7 @@
           <p:cNvPr id="239" name="Google Shape;239;p18">
             <a:extLst>
               <a:ext uri="{FF2B5EF4-FFF2-40B4-BE49-F238E27FC236}">
-                <a16:creationId xmlns:a16="http://schemas.microsoft.com/office/drawing/2014/main" id="{94360326-5D8B-C212-95A1-250F9BC6BA79}"/>
+                <a16:creationId xmlns:a16="http://schemas.microsoft.com/office/drawing/2014/main" id="{2F6C7C27-18F3-8E62-2146-D33D0328D682}"/>
               </a:ext>
             </a:extLst>
           </p:cNvPr>
@@ -7519,7 +7519,7 @@
         </p:nvSpPr>
         <p:spPr>
           <a:xfrm>
-            <a:off x="1035666" y="3781476"/>
+            <a:off x="1035666" y="3988327"/>
             <a:ext cx="2205042" cy="528303"/>
           </a:xfrm>
           <a:prstGeom prst="rect">
@@ -7566,7 +7566,7 @@
           <p:cNvPr id="240" name="Google Shape;240;p18">
             <a:extLst>
               <a:ext uri="{FF2B5EF4-FFF2-40B4-BE49-F238E27FC236}">
-                <a16:creationId xmlns:a16="http://schemas.microsoft.com/office/drawing/2014/main" id="{23B2D91F-8F61-2CDC-8859-2659ED0B29F2}"/>
+                <a16:creationId xmlns:a16="http://schemas.microsoft.com/office/drawing/2014/main" id="{2DAD3283-8A87-1182-8FA7-8E684AECF78A}"/>
               </a:ext>
             </a:extLst>
           </p:cNvPr>
@@ -7575,7 +7575,7 @@
         </p:nvSpPr>
         <p:spPr>
           <a:xfrm>
-            <a:off x="190069" y="7749716"/>
+            <a:off x="190069" y="7956567"/>
             <a:ext cx="4170519" cy="651414"/>
           </a:xfrm>
           <a:prstGeom prst="rect">
@@ -7627,7 +7627,7 @@
           <p:cNvPr id="241" name="Google Shape;241;p18">
             <a:extLst>
               <a:ext uri="{FF2B5EF4-FFF2-40B4-BE49-F238E27FC236}">
-                <a16:creationId xmlns:a16="http://schemas.microsoft.com/office/drawing/2014/main" id="{41A7879C-D347-4F51-4DBE-100268177465}"/>
+                <a16:creationId xmlns:a16="http://schemas.microsoft.com/office/drawing/2014/main" id="{D7B54ED7-4D8D-C4AF-AF71-7B4712CD8881}"/>
               </a:ext>
             </a:extLst>
           </p:cNvPr>
@@ -7636,7 +7636,7 @@
         </p:nvSpPr>
         <p:spPr>
           <a:xfrm>
-            <a:off x="366097" y="8845591"/>
+            <a:off x="366097" y="9052442"/>
             <a:ext cx="3599079" cy="1019710"/>
           </a:xfrm>
           <a:prstGeom prst="rect">
@@ -7671,7 +7671,7 @@
           <p:cNvPr id="242" name="Google Shape;242;p18">
             <a:extLst>
               <a:ext uri="{FF2B5EF4-FFF2-40B4-BE49-F238E27FC236}">
-                <a16:creationId xmlns:a16="http://schemas.microsoft.com/office/drawing/2014/main" id="{AF5A1450-C2C9-1914-9E38-151246D2BDF2}"/>
+                <a16:creationId xmlns:a16="http://schemas.microsoft.com/office/drawing/2014/main" id="{F0534D39-7DDD-09CB-944E-0F1BE8BC9396}"/>
               </a:ext>
             </a:extLst>
           </p:cNvPr>
@@ -7680,7 +7680,7 @@
         </p:nvSpPr>
         <p:spPr>
           <a:xfrm>
-            <a:off x="0" y="9040390"/>
+            <a:off x="0" y="9247241"/>
             <a:ext cx="4846757" cy="836080"/>
           </a:xfrm>
           <a:prstGeom prst="rect">
@@ -7788,7 +7788,7 @@
           <p:cNvPr id="243" name="Google Shape;243;p18">
             <a:extLst>
               <a:ext uri="{FF2B5EF4-FFF2-40B4-BE49-F238E27FC236}">
-                <a16:creationId xmlns:a16="http://schemas.microsoft.com/office/drawing/2014/main" id="{437BA2D5-830A-A169-A8F6-4DF6BE4B5333}"/>
+                <a16:creationId xmlns:a16="http://schemas.microsoft.com/office/drawing/2014/main" id="{EEB05D1A-12AF-9AC2-D38C-92CE2B25EF9A}"/>
               </a:ext>
             </a:extLst>
           </p:cNvPr>
@@ -7797,7 +7797,7 @@
         </p:nvSpPr>
         <p:spPr>
           <a:xfrm>
-            <a:off x="274320" y="8302641"/>
+            <a:off x="274320" y="8509492"/>
             <a:ext cx="3702543" cy="666803"/>
           </a:xfrm>
           <a:prstGeom prst="rect">
@@ -7843,7 +7843,7 @@
           <p:cNvPr id="244" name="Google Shape;244;p18">
             <a:extLst>
               <a:ext uri="{FF2B5EF4-FFF2-40B4-BE49-F238E27FC236}">
-                <a16:creationId xmlns:a16="http://schemas.microsoft.com/office/drawing/2014/main" id="{8646127D-B17E-2A8F-756B-02F2F1257E17}"/>
+                <a16:creationId xmlns:a16="http://schemas.microsoft.com/office/drawing/2014/main" id="{DCC8BFCE-6427-9E92-E8CF-4E56D5D57281}"/>
               </a:ext>
             </a:extLst>
           </p:cNvPr>
@@ -7852,7 +7852,7 @@
         </p:nvSpPr>
         <p:spPr>
           <a:xfrm>
-            <a:off x="1196058" y="8767140"/>
+            <a:off x="1196058" y="8973991"/>
             <a:ext cx="1801990" cy="528303"/>
           </a:xfrm>
           <a:prstGeom prst="rect">
@@ -7899,7 +7899,7 @@
           <p:cNvPr id="324" name="Google Shape;324;p18">
             <a:extLst>
               <a:ext uri="{FF2B5EF4-FFF2-40B4-BE49-F238E27FC236}">
-                <a16:creationId xmlns:a16="http://schemas.microsoft.com/office/drawing/2014/main" id="{18328BE4-A8A2-804A-5D0A-15F094C636AE}"/>
+                <a16:creationId xmlns:a16="http://schemas.microsoft.com/office/drawing/2014/main" id="{5322A7A4-F27E-4DF5-4546-2E7C20A90823}"/>
               </a:ext>
             </a:extLst>
           </p:cNvPr>
@@ -7908,7 +7908,7 @@
         </p:nvSpPr>
         <p:spPr>
           <a:xfrm>
-            <a:off x="4317379" y="3604236"/>
+            <a:off x="4317379" y="3811087"/>
             <a:ext cx="678035" cy="3387142"/>
           </a:xfrm>
           <a:prstGeom prst="rect">
@@ -7941,7 +7941,7 @@
           <p:cNvPr id="325" name="Google Shape;325;p18">
             <a:extLst>
               <a:ext uri="{FF2B5EF4-FFF2-40B4-BE49-F238E27FC236}">
-                <a16:creationId xmlns:a16="http://schemas.microsoft.com/office/drawing/2014/main" id="{B5364CD8-859A-0499-4C9B-57B714FB37F6}"/>
+                <a16:creationId xmlns:a16="http://schemas.microsoft.com/office/drawing/2014/main" id="{19B4817A-ECDF-9826-59BA-644D3E5BCAC6}"/>
               </a:ext>
             </a:extLst>
           </p:cNvPr>
@@ -7950,7 +7950,7 @@
         </p:nvSpPr>
         <p:spPr>
           <a:xfrm>
-            <a:off x="4182474" y="3322603"/>
+            <a:off x="4182474" y="3529454"/>
             <a:ext cx="1016224" cy="426638"/>
           </a:xfrm>
           <a:prstGeom prst="rect">
@@ -7996,7 +7996,7 @@
           <p:cNvPr id="326" name="Google Shape;326;p18">
             <a:extLst>
               <a:ext uri="{FF2B5EF4-FFF2-40B4-BE49-F238E27FC236}">
-                <a16:creationId xmlns:a16="http://schemas.microsoft.com/office/drawing/2014/main" id="{00719950-966D-317B-D840-7CFA98853777}"/>
+                <a16:creationId xmlns:a16="http://schemas.microsoft.com/office/drawing/2014/main" id="{B7B7D331-336D-A75E-2C1A-A32FA64F7BB6}"/>
               </a:ext>
             </a:extLst>
           </p:cNvPr>
@@ -8005,7 +8005,7 @@
         </p:nvSpPr>
         <p:spPr>
           <a:xfrm>
-            <a:off x="4194019" y="3045285"/>
+            <a:off x="4194019" y="3252136"/>
             <a:ext cx="5130353" cy="4249994"/>
           </a:xfrm>
           <a:prstGeom prst="rect">
@@ -8038,7 +8038,7 @@
           <p:cNvPr id="327" name="Google Shape;327;p18">
             <a:extLst>
               <a:ext uri="{FF2B5EF4-FFF2-40B4-BE49-F238E27FC236}">
-                <a16:creationId xmlns:a16="http://schemas.microsoft.com/office/drawing/2014/main" id="{62E10FFC-97DC-21C6-8A5B-0F49697D4990}"/>
+                <a16:creationId xmlns:a16="http://schemas.microsoft.com/office/drawing/2014/main" id="{21796620-378C-776A-B1AB-5699F313D3B4}"/>
               </a:ext>
             </a:extLst>
           </p:cNvPr>
@@ -8047,7 +8047,7 @@
         </p:nvSpPr>
         <p:spPr>
           <a:xfrm>
-            <a:off x="5354454" y="4556511"/>
+            <a:off x="5354454" y="4763362"/>
             <a:ext cx="1008333" cy="824083"/>
           </a:xfrm>
           <a:prstGeom prst="rect">
@@ -8080,7 +8080,7 @@
           <p:cNvPr id="328" name="Google Shape;328;p18">
             <a:extLst>
               <a:ext uri="{FF2B5EF4-FFF2-40B4-BE49-F238E27FC236}">
-                <a16:creationId xmlns:a16="http://schemas.microsoft.com/office/drawing/2014/main" id="{5DE23F89-F903-3084-45F7-33CEDE89C94E}"/>
+                <a16:creationId xmlns:a16="http://schemas.microsoft.com/office/drawing/2014/main" id="{1E8B5BF2-8139-1353-9570-B4E32B4CAD0B}"/>
               </a:ext>
             </a:extLst>
           </p:cNvPr>
@@ -8089,7 +8089,7 @@
         </p:nvSpPr>
         <p:spPr>
           <a:xfrm>
-            <a:off x="5296279" y="4553712"/>
+            <a:off x="5296279" y="4760563"/>
             <a:ext cx="1160964" cy="426638"/>
           </a:xfrm>
           <a:prstGeom prst="rect">
@@ -8135,7 +8135,7 @@
           <p:cNvPr id="329" name="Google Shape;329;p18">
             <a:extLst>
               <a:ext uri="{FF2B5EF4-FFF2-40B4-BE49-F238E27FC236}">
-                <a16:creationId xmlns:a16="http://schemas.microsoft.com/office/drawing/2014/main" id="{F5BFAB30-BA7D-7157-6C0F-F2AAA05850BE}"/>
+                <a16:creationId xmlns:a16="http://schemas.microsoft.com/office/drawing/2014/main" id="{A1194851-6D13-2E62-F107-C71A57B47CDE}"/>
               </a:ext>
             </a:extLst>
           </p:cNvPr>
@@ -8146,7 +8146,7 @@
         </p:nvCxnSpPr>
         <p:spPr>
           <a:xfrm>
-            <a:off x="5952575" y="5385245"/>
+            <a:off x="5952575" y="5592096"/>
             <a:ext cx="0" cy="722646"/>
           </a:xfrm>
           <a:prstGeom prst="straightConnector1">
@@ -8169,7 +8169,7 @@
           <p:cNvPr id="330" name="Google Shape;330;p18">
             <a:extLst>
               <a:ext uri="{FF2B5EF4-FFF2-40B4-BE49-F238E27FC236}">
-                <a16:creationId xmlns:a16="http://schemas.microsoft.com/office/drawing/2014/main" id="{C7211592-B4C7-1386-C225-8E1FD1F8D4DD}"/>
+                <a16:creationId xmlns:a16="http://schemas.microsoft.com/office/drawing/2014/main" id="{AA816F21-6D3A-9E99-55E5-0583DD1ECC53}"/>
               </a:ext>
             </a:extLst>
           </p:cNvPr>
@@ -8178,7 +8178,7 @@
         </p:nvSpPr>
         <p:spPr>
           <a:xfrm>
-            <a:off x="5033888" y="6033865"/>
+            <a:off x="5033888" y="6240716"/>
             <a:ext cx="1929855" cy="426638"/>
           </a:xfrm>
           <a:prstGeom prst="rect">
@@ -8224,7 +8224,7 @@
           <p:cNvPr id="331" name="Google Shape;331;p18">
             <a:extLst>
               <a:ext uri="{FF2B5EF4-FFF2-40B4-BE49-F238E27FC236}">
-                <a16:creationId xmlns:a16="http://schemas.microsoft.com/office/drawing/2014/main" id="{460805C2-21B9-E041-579E-0757DE1D902E}"/>
+                <a16:creationId xmlns:a16="http://schemas.microsoft.com/office/drawing/2014/main" id="{8D9FB723-5D1D-6EDF-D2FB-F203561D5C7F}"/>
               </a:ext>
             </a:extLst>
           </p:cNvPr>
@@ -8233,7 +8233,7 @@
         </p:nvSpPr>
         <p:spPr>
           <a:xfrm>
-            <a:off x="7515948" y="4568322"/>
+            <a:off x="7515948" y="4775173"/>
             <a:ext cx="1769547" cy="846542"/>
           </a:xfrm>
           <a:prstGeom prst="rect">
@@ -8266,7 +8266,7 @@
           <p:cNvPr id="332" name="Google Shape;332;p18">
             <a:extLst>
               <a:ext uri="{FF2B5EF4-FFF2-40B4-BE49-F238E27FC236}">
-                <a16:creationId xmlns:a16="http://schemas.microsoft.com/office/drawing/2014/main" id="{5CCFCD62-09D7-5319-4E9D-2899EEC88E8E}"/>
+                <a16:creationId xmlns:a16="http://schemas.microsoft.com/office/drawing/2014/main" id="{A393435B-7925-2CF9-25C3-B5DC33364087}"/>
               </a:ext>
             </a:extLst>
           </p:cNvPr>
@@ -8275,7 +8275,7 @@
         </p:nvSpPr>
         <p:spPr>
           <a:xfrm>
-            <a:off x="7418473" y="4553712"/>
+            <a:off x="7418473" y="4760563"/>
             <a:ext cx="2000373" cy="427795"/>
           </a:xfrm>
           <a:prstGeom prst="rect">
@@ -8321,7 +8321,7 @@
           <p:cNvPr id="333" name="Google Shape;333;p18">
             <a:extLst>
               <a:ext uri="{FF2B5EF4-FFF2-40B4-BE49-F238E27FC236}">
-                <a16:creationId xmlns:a16="http://schemas.microsoft.com/office/drawing/2014/main" id="{AF7D27F9-2CDB-9B59-FB07-5DA92CA191FA}"/>
+                <a16:creationId xmlns:a16="http://schemas.microsoft.com/office/drawing/2014/main" id="{3F71910C-F125-CA4B-BAD6-36060544B336}"/>
               </a:ext>
             </a:extLst>
           </p:cNvPr>
@@ -8330,7 +8330,7 @@
         </p:nvCxnSpPr>
         <p:spPr>
           <a:xfrm rot="10800000" flipH="1">
-            <a:off x="6492442" y="4936484"/>
+            <a:off x="6492442" y="5143335"/>
             <a:ext cx="966625" cy="1375"/>
           </a:xfrm>
           <a:prstGeom prst="straightConnector1">
@@ -8353,7 +8353,7 @@
           <p:cNvPr id="334" name="Google Shape;334;p18">
             <a:extLst>
               <a:ext uri="{FF2B5EF4-FFF2-40B4-BE49-F238E27FC236}">
-                <a16:creationId xmlns:a16="http://schemas.microsoft.com/office/drawing/2014/main" id="{55299D25-3D69-31F2-ACB3-7F5BDE1D53E5}"/>
+                <a16:creationId xmlns:a16="http://schemas.microsoft.com/office/drawing/2014/main" id="{8651D400-6C37-A164-CB04-AD310A5CD0F3}"/>
               </a:ext>
             </a:extLst>
           </p:cNvPr>
@@ -8362,7 +8362,7 @@
         </p:nvCxnSpPr>
         <p:spPr>
           <a:xfrm rot="10800000">
-            <a:off x="6476284" y="5173043"/>
+            <a:off x="6476284" y="5379894"/>
             <a:ext cx="966625" cy="1375"/>
           </a:xfrm>
           <a:prstGeom prst="straightConnector1">
@@ -8385,7 +8385,7 @@
           <p:cNvPr id="335" name="Google Shape;335;p18">
             <a:extLst>
               <a:ext uri="{FF2B5EF4-FFF2-40B4-BE49-F238E27FC236}">
-                <a16:creationId xmlns:a16="http://schemas.microsoft.com/office/drawing/2014/main" id="{00E874F6-0641-D49D-A042-7C9E9B4F6787}"/>
+                <a16:creationId xmlns:a16="http://schemas.microsoft.com/office/drawing/2014/main" id="{63541B82-28FF-8C39-6A4A-519A3653257D}"/>
               </a:ext>
             </a:extLst>
           </p:cNvPr>
@@ -8394,7 +8394,7 @@
         </p:nvSpPr>
         <p:spPr>
           <a:xfrm>
-            <a:off x="6727292" y="5283981"/>
+            <a:off x="6727292" y="5490832"/>
             <a:ext cx="645652" cy="426638"/>
           </a:xfrm>
           <a:prstGeom prst="rect">
@@ -8440,7 +8440,7 @@
           <p:cNvPr id="337" name="Google Shape;337;p18">
             <a:extLst>
               <a:ext uri="{FF2B5EF4-FFF2-40B4-BE49-F238E27FC236}">
-                <a16:creationId xmlns:a16="http://schemas.microsoft.com/office/drawing/2014/main" id="{030CB4A7-0046-DBFB-D066-8AC1B94A1C75}"/>
+                <a16:creationId xmlns:a16="http://schemas.microsoft.com/office/drawing/2014/main" id="{65974765-C3D8-DC3E-7D43-48BE860AE22B}"/>
               </a:ext>
             </a:extLst>
           </p:cNvPr>
@@ -8449,7 +8449,7 @@
         </p:nvSpPr>
         <p:spPr>
           <a:xfrm>
-            <a:off x="6277667" y="4463179"/>
+            <a:off x="6277667" y="4670030"/>
             <a:ext cx="1331930" cy="426638"/>
           </a:xfrm>
           <a:prstGeom prst="rect">
@@ -8495,7 +8495,7 @@
           <p:cNvPr id="342" name="Google Shape;342;p18">
             <a:extLst>
               <a:ext uri="{FF2B5EF4-FFF2-40B4-BE49-F238E27FC236}">
-                <a16:creationId xmlns:a16="http://schemas.microsoft.com/office/drawing/2014/main" id="{CEFA9090-6D3E-C16C-49E4-6F97BD56B6C4}"/>
+                <a16:creationId xmlns:a16="http://schemas.microsoft.com/office/drawing/2014/main" id="{DC28133A-639B-19AA-16AC-64C63E9EC678}"/>
               </a:ext>
             </a:extLst>
           </p:cNvPr>
@@ -8504,7 +8504,7 @@
         </p:nvSpPr>
         <p:spPr>
           <a:xfrm>
-            <a:off x="6544679" y="5602980"/>
+            <a:off x="6544679" y="5809831"/>
             <a:ext cx="204417" cy="175083"/>
           </a:xfrm>
           <a:prstGeom prst="wedgeRectCallout">
@@ -8542,7 +8542,7 @@
           <p:cNvPr id="343" name="Google Shape;343;p18">
             <a:extLst>
               <a:ext uri="{FF2B5EF4-FFF2-40B4-BE49-F238E27FC236}">
-                <a16:creationId xmlns:a16="http://schemas.microsoft.com/office/drawing/2014/main" id="{0702CD3B-73BA-B03C-DF87-C4E7A8917E52}"/>
+                <a16:creationId xmlns:a16="http://schemas.microsoft.com/office/drawing/2014/main" id="{76967EAB-3C79-D80B-9FC1-D1350B0F0683}"/>
               </a:ext>
             </a:extLst>
           </p:cNvPr>
@@ -8551,7 +8551,7 @@
         </p:nvSpPr>
         <p:spPr>
           <a:xfrm>
-            <a:off x="4467992" y="3197928"/>
+            <a:off x="4467992" y="3404779"/>
             <a:ext cx="418917" cy="426638"/>
           </a:xfrm>
           <a:prstGeom prst="rect">
@@ -8597,7 +8597,7 @@
           <p:cNvPr id="344" name="Google Shape;344;p18">
             <a:extLst>
               <a:ext uri="{FF2B5EF4-FFF2-40B4-BE49-F238E27FC236}">
-                <a16:creationId xmlns:a16="http://schemas.microsoft.com/office/drawing/2014/main" id="{DD08C4A6-F1EF-9E63-A1E0-6B0D71CE3519}"/>
+                <a16:creationId xmlns:a16="http://schemas.microsoft.com/office/drawing/2014/main" id="{9A28E161-8D1E-4767-567B-4F0BDA6FE823}"/>
               </a:ext>
             </a:extLst>
           </p:cNvPr>
@@ -8606,7 +8606,7 @@
         </p:nvSpPr>
         <p:spPr>
           <a:xfrm>
-            <a:off x="6754055" y="4635132"/>
+            <a:off x="6754055" y="4841983"/>
             <a:ext cx="418917" cy="426638"/>
           </a:xfrm>
           <a:prstGeom prst="rect">
@@ -8652,7 +8652,7 @@
           <p:cNvPr id="345" name="Google Shape;345;p18">
             <a:extLst>
               <a:ext uri="{FF2B5EF4-FFF2-40B4-BE49-F238E27FC236}">
-                <a16:creationId xmlns:a16="http://schemas.microsoft.com/office/drawing/2014/main" id="{0F252196-D84D-FC26-5979-659B7774DEE6}"/>
+                <a16:creationId xmlns:a16="http://schemas.microsoft.com/office/drawing/2014/main" id="{3428B935-8BD8-820D-B3CF-3E297E973099}"/>
               </a:ext>
             </a:extLst>
           </p:cNvPr>
@@ -8661,7 +8661,7 @@
         </p:nvSpPr>
         <p:spPr>
           <a:xfrm>
-            <a:off x="6786908" y="5099880"/>
+            <a:off x="6786908" y="5306731"/>
             <a:ext cx="418917" cy="426638"/>
           </a:xfrm>
           <a:prstGeom prst="rect">
@@ -8707,7 +8707,7 @@
           <p:cNvPr id="346" name="Google Shape;346;p18">
             <a:extLst>
               <a:ext uri="{FF2B5EF4-FFF2-40B4-BE49-F238E27FC236}">
-                <a16:creationId xmlns:a16="http://schemas.microsoft.com/office/drawing/2014/main" id="{953CBEF9-842A-1FDE-B505-348CCA050158}"/>
+                <a16:creationId xmlns:a16="http://schemas.microsoft.com/office/drawing/2014/main" id="{3F2DD0C9-6926-9226-658E-4CB377FFCB21}"/>
               </a:ext>
             </a:extLst>
           </p:cNvPr>
@@ -8716,7 +8716,7 @@
         </p:nvSpPr>
         <p:spPr>
           <a:xfrm>
-            <a:off x="8152696" y="4735909"/>
+            <a:off x="8152696" y="4942760"/>
             <a:ext cx="418917" cy="426638"/>
           </a:xfrm>
           <a:prstGeom prst="rect">
@@ -8762,7 +8762,7 @@
           <p:cNvPr id="347" name="Google Shape;347;p18">
             <a:extLst>
               <a:ext uri="{FF2B5EF4-FFF2-40B4-BE49-F238E27FC236}">
-                <a16:creationId xmlns:a16="http://schemas.microsoft.com/office/drawing/2014/main" id="{5C956A37-F5B8-A1D2-67FB-2D879E9A02BA}"/>
+                <a16:creationId xmlns:a16="http://schemas.microsoft.com/office/drawing/2014/main" id="{24AC6BDF-7B08-EC4A-F2BB-A221FF3B1B13}"/>
               </a:ext>
             </a:extLst>
           </p:cNvPr>
@@ -8773,7 +8773,7 @@
         </p:nvSpPr>
         <p:spPr>
           <a:xfrm>
-            <a:off x="7823901" y="5062324"/>
+            <a:off x="7823901" y="5269175"/>
             <a:ext cx="287942" cy="259172"/>
           </a:xfrm>
           <a:prstGeom prst="rect">
@@ -8806,7 +8806,7 @@
           <p:cNvPr id="349" name="Google Shape;349;p18">
             <a:extLst>
               <a:ext uri="{FF2B5EF4-FFF2-40B4-BE49-F238E27FC236}">
-                <a16:creationId xmlns:a16="http://schemas.microsoft.com/office/drawing/2014/main" id="{94B2CC07-2998-A372-1D43-2B446DD06470}"/>
+                <a16:creationId xmlns:a16="http://schemas.microsoft.com/office/drawing/2014/main" id="{B67CC23C-7820-2754-6977-29B7B746119B}"/>
               </a:ext>
             </a:extLst>
           </p:cNvPr>
@@ -8815,7 +8815,7 @@
         </p:nvSpPr>
         <p:spPr>
           <a:xfrm>
-            <a:off x="7737364" y="5012516"/>
+            <a:off x="7737364" y="5219367"/>
             <a:ext cx="475871" cy="194398"/>
           </a:xfrm>
           <a:prstGeom prst="rect">
@@ -8858,7 +8858,7 @@
           <p:cNvPr id="357" name="Google Shape;357;p18">
             <a:extLst>
               <a:ext uri="{FF2B5EF4-FFF2-40B4-BE49-F238E27FC236}">
-                <a16:creationId xmlns:a16="http://schemas.microsoft.com/office/drawing/2014/main" id="{4B1AEB97-D4DB-FF9B-DAE3-0CBAF7FC8D5E}"/>
+                <a16:creationId xmlns:a16="http://schemas.microsoft.com/office/drawing/2014/main" id="{14353DC6-876C-B3FC-605E-D361B2046DC0}"/>
               </a:ext>
             </a:extLst>
           </p:cNvPr>
@@ -8870,7 +8870,7 @@
         </p:nvCxnSpPr>
         <p:spPr>
           <a:xfrm rot="5400000" flipH="1" flipV="1">
-            <a:off x="7147220" y="3261956"/>
+            <a:off x="7147220" y="3468807"/>
             <a:ext cx="5956" cy="2583154"/>
           </a:xfrm>
           <a:prstGeom prst="bentConnector3">
@@ -8895,7 +8895,7 @@
           <p:cNvPr id="358" name="Google Shape;358;p18">
             <a:extLst>
               <a:ext uri="{FF2B5EF4-FFF2-40B4-BE49-F238E27FC236}">
-                <a16:creationId xmlns:a16="http://schemas.microsoft.com/office/drawing/2014/main" id="{0D2C0A36-F16B-7193-635E-79BD871CF067}"/>
+                <a16:creationId xmlns:a16="http://schemas.microsoft.com/office/drawing/2014/main" id="{1B45B08D-1675-CF51-4F4A-65142C4D8901}"/>
               </a:ext>
             </a:extLst>
           </p:cNvPr>
@@ -8904,7 +8904,7 @@
         </p:nvSpPr>
         <p:spPr>
           <a:xfrm>
-            <a:off x="6221193" y="4001201"/>
+            <a:off x="6221193" y="4208052"/>
             <a:ext cx="1814639" cy="289208"/>
           </a:xfrm>
           <a:prstGeom prst="rect">
@@ -8950,7 +8950,7 @@
           <p:cNvPr id="359" name="Google Shape;359;p18">
             <a:extLst>
               <a:ext uri="{FF2B5EF4-FFF2-40B4-BE49-F238E27FC236}">
-                <a16:creationId xmlns:a16="http://schemas.microsoft.com/office/drawing/2014/main" id="{46467B35-27D8-606F-905D-A2807274B8F7}"/>
+                <a16:creationId xmlns:a16="http://schemas.microsoft.com/office/drawing/2014/main" id="{3F1F7670-7E5B-3014-E699-68130A36A786}"/>
               </a:ext>
             </a:extLst>
           </p:cNvPr>
@@ -8959,7 +8959,7 @@
         </p:nvGrpSpPr>
         <p:grpSpPr>
           <a:xfrm>
-            <a:off x="4419669" y="3921890"/>
+            <a:off x="4419669" y="4128741"/>
             <a:ext cx="469333" cy="289208"/>
             <a:chOff x="3007175" y="1757600"/>
             <a:chExt cx="307200" cy="189300"/>
@@ -8970,7 +8970,7 @@
             <p:cNvPr id="360" name="Google Shape;360;p18">
               <a:extLst>
                 <a:ext uri="{FF2B5EF4-FFF2-40B4-BE49-F238E27FC236}">
-                  <a16:creationId xmlns:a16="http://schemas.microsoft.com/office/drawing/2014/main" id="{5552ED3D-7140-5BCF-0E0D-CB0C4B03AB58}"/>
+                  <a16:creationId xmlns:a16="http://schemas.microsoft.com/office/drawing/2014/main" id="{72219DE9-32D5-E37D-9E10-77FD070CE05A}"/>
                 </a:ext>
               </a:extLst>
             </p:cNvPr>
@@ -9012,7 +9012,7 @@
             <p:cNvPr id="361" name="Google Shape;361;p18">
               <a:extLst>
                 <a:ext uri="{FF2B5EF4-FFF2-40B4-BE49-F238E27FC236}">
-                  <a16:creationId xmlns:a16="http://schemas.microsoft.com/office/drawing/2014/main" id="{EF56074B-01E2-A143-0A4D-05CC270259BE}"/>
+                  <a16:creationId xmlns:a16="http://schemas.microsoft.com/office/drawing/2014/main" id="{1EBB4147-3F02-DA9B-7B7D-1485C37D9D1F}"/>
                 </a:ext>
               </a:extLst>
             </p:cNvPr>
@@ -9054,7 +9054,7 @@
             <p:cNvPr id="362" name="Google Shape;362;p18">
               <a:extLst>
                 <a:ext uri="{FF2B5EF4-FFF2-40B4-BE49-F238E27FC236}">
-                  <a16:creationId xmlns:a16="http://schemas.microsoft.com/office/drawing/2014/main" id="{D1A7DB24-FC78-60E8-50FB-73BDDFB7F4D6}"/>
+                  <a16:creationId xmlns:a16="http://schemas.microsoft.com/office/drawing/2014/main" id="{7CD1E85B-07B2-48E5-188B-F0D15BE3781E}"/>
                 </a:ext>
               </a:extLst>
             </p:cNvPr>
@@ -9096,7 +9096,7 @@
             <p:cNvPr id="363" name="Google Shape;363;p18">
               <a:extLst>
                 <a:ext uri="{FF2B5EF4-FFF2-40B4-BE49-F238E27FC236}">
-                  <a16:creationId xmlns:a16="http://schemas.microsoft.com/office/drawing/2014/main" id="{5066A050-0897-F4DC-5E98-874DBAC867B3}"/>
+                  <a16:creationId xmlns:a16="http://schemas.microsoft.com/office/drawing/2014/main" id="{4EDF2055-2CD4-31D9-4A7B-D13B212CB4FA}"/>
                 </a:ext>
               </a:extLst>
             </p:cNvPr>
@@ -9138,7 +9138,7 @@
             <p:cNvPr id="364" name="Google Shape;364;p18">
               <a:extLst>
                 <a:ext uri="{FF2B5EF4-FFF2-40B4-BE49-F238E27FC236}">
-                  <a16:creationId xmlns:a16="http://schemas.microsoft.com/office/drawing/2014/main" id="{75074D12-BF27-F10D-FA52-0768FB77B959}"/>
+                  <a16:creationId xmlns:a16="http://schemas.microsoft.com/office/drawing/2014/main" id="{E5CCA4F4-A7E4-0812-0E05-16FFF55EF96D}"/>
                 </a:ext>
               </a:extLst>
             </p:cNvPr>
@@ -9170,7 +9170,7 @@
             <p:cNvPr id="365" name="Google Shape;365;p18">
               <a:extLst>
                 <a:ext uri="{FF2B5EF4-FFF2-40B4-BE49-F238E27FC236}">
-                  <a16:creationId xmlns:a16="http://schemas.microsoft.com/office/drawing/2014/main" id="{EDFD62A3-0370-575F-CD05-44296992C3D1}"/>
+                  <a16:creationId xmlns:a16="http://schemas.microsoft.com/office/drawing/2014/main" id="{245A51B7-98F2-D8FC-246C-C82E896E6979}"/>
                 </a:ext>
               </a:extLst>
             </p:cNvPr>
@@ -9202,7 +9202,7 @@
             <p:cNvPr id="366" name="Google Shape;366;p18">
               <a:extLst>
                 <a:ext uri="{FF2B5EF4-FFF2-40B4-BE49-F238E27FC236}">
-                  <a16:creationId xmlns:a16="http://schemas.microsoft.com/office/drawing/2014/main" id="{1BC1C72C-AF8E-2620-CAB6-B556AFB37EC8}"/>
+                  <a16:creationId xmlns:a16="http://schemas.microsoft.com/office/drawing/2014/main" id="{AD6FCB20-628E-C9FF-4192-44DAD54885F6}"/>
                 </a:ext>
               </a:extLst>
             </p:cNvPr>
@@ -9235,7 +9235,7 @@
           <p:cNvPr id="367" name="Google Shape;367;p18">
             <a:extLst>
               <a:ext uri="{FF2B5EF4-FFF2-40B4-BE49-F238E27FC236}">
-                <a16:creationId xmlns:a16="http://schemas.microsoft.com/office/drawing/2014/main" id="{C392C204-B4E0-5FF9-448F-3274F463595B}"/>
+                <a16:creationId xmlns:a16="http://schemas.microsoft.com/office/drawing/2014/main" id="{87DF8BD0-5FE8-902F-B8E6-A917A3D88659}"/>
               </a:ext>
             </a:extLst>
           </p:cNvPr>
@@ -9244,7 +9244,7 @@
         </p:nvGrpSpPr>
         <p:grpSpPr>
           <a:xfrm>
-            <a:off x="4419669" y="4560327"/>
+            <a:off x="4419669" y="4767178"/>
             <a:ext cx="469333" cy="289208"/>
             <a:chOff x="3007175" y="1757600"/>
             <a:chExt cx="307200" cy="189300"/>
@@ -9255,7 +9255,7 @@
             <p:cNvPr id="368" name="Google Shape;368;p18">
               <a:extLst>
                 <a:ext uri="{FF2B5EF4-FFF2-40B4-BE49-F238E27FC236}">
-                  <a16:creationId xmlns:a16="http://schemas.microsoft.com/office/drawing/2014/main" id="{9566D899-0F79-D97D-39FA-1BAB104D7438}"/>
+                  <a16:creationId xmlns:a16="http://schemas.microsoft.com/office/drawing/2014/main" id="{B379C597-A4EB-CA4E-7138-25F999B2E650}"/>
                 </a:ext>
               </a:extLst>
             </p:cNvPr>
@@ -9297,7 +9297,7 @@
             <p:cNvPr id="369" name="Google Shape;369;p18">
               <a:extLst>
                 <a:ext uri="{FF2B5EF4-FFF2-40B4-BE49-F238E27FC236}">
-                  <a16:creationId xmlns:a16="http://schemas.microsoft.com/office/drawing/2014/main" id="{2914AA9F-B033-4ECA-9CE2-C4C06F6C4FC6}"/>
+                  <a16:creationId xmlns:a16="http://schemas.microsoft.com/office/drawing/2014/main" id="{732D05AD-9F11-284C-8064-91FD86991C3B}"/>
                 </a:ext>
               </a:extLst>
             </p:cNvPr>
@@ -9339,7 +9339,7 @@
             <p:cNvPr id="370" name="Google Shape;370;p18">
               <a:extLst>
                 <a:ext uri="{FF2B5EF4-FFF2-40B4-BE49-F238E27FC236}">
-                  <a16:creationId xmlns:a16="http://schemas.microsoft.com/office/drawing/2014/main" id="{84D65723-88F3-4E1B-8D2A-A8EC1A102B5C}"/>
+                  <a16:creationId xmlns:a16="http://schemas.microsoft.com/office/drawing/2014/main" id="{02C9509F-59FC-3942-608A-66E39FA1FC10}"/>
                 </a:ext>
               </a:extLst>
             </p:cNvPr>
@@ -9381,7 +9381,7 @@
             <p:cNvPr id="371" name="Google Shape;371;p18">
               <a:extLst>
                 <a:ext uri="{FF2B5EF4-FFF2-40B4-BE49-F238E27FC236}">
-                  <a16:creationId xmlns:a16="http://schemas.microsoft.com/office/drawing/2014/main" id="{AF81DC4A-11A5-CC8A-B2A4-DFC170D411A7}"/>
+                  <a16:creationId xmlns:a16="http://schemas.microsoft.com/office/drawing/2014/main" id="{B27E45CB-7DC8-E716-4374-D6CD81D73D7D}"/>
                 </a:ext>
               </a:extLst>
             </p:cNvPr>
@@ -9423,7 +9423,7 @@
             <p:cNvPr id="372" name="Google Shape;372;p18">
               <a:extLst>
                 <a:ext uri="{FF2B5EF4-FFF2-40B4-BE49-F238E27FC236}">
-                  <a16:creationId xmlns:a16="http://schemas.microsoft.com/office/drawing/2014/main" id="{D3335454-D0DD-8874-643C-3D25E590298F}"/>
+                  <a16:creationId xmlns:a16="http://schemas.microsoft.com/office/drawing/2014/main" id="{8838D185-A499-FB6F-0BD9-B0B94F1AEFA7}"/>
                 </a:ext>
               </a:extLst>
             </p:cNvPr>
@@ -9455,7 +9455,7 @@
             <p:cNvPr id="373" name="Google Shape;373;p18">
               <a:extLst>
                 <a:ext uri="{FF2B5EF4-FFF2-40B4-BE49-F238E27FC236}">
-                  <a16:creationId xmlns:a16="http://schemas.microsoft.com/office/drawing/2014/main" id="{C5EC53F7-F962-373C-CE1F-808E5A5E8B95}"/>
+                  <a16:creationId xmlns:a16="http://schemas.microsoft.com/office/drawing/2014/main" id="{604D8E2A-0CE3-761D-591E-AC45ACB4A579}"/>
                 </a:ext>
               </a:extLst>
             </p:cNvPr>
@@ -9487,7 +9487,7 @@
             <p:cNvPr id="374" name="Google Shape;374;p18">
               <a:extLst>
                 <a:ext uri="{FF2B5EF4-FFF2-40B4-BE49-F238E27FC236}">
-                  <a16:creationId xmlns:a16="http://schemas.microsoft.com/office/drawing/2014/main" id="{F96846E3-7B27-1B3F-E55F-DC66BD344993}"/>
+                  <a16:creationId xmlns:a16="http://schemas.microsoft.com/office/drawing/2014/main" id="{BB160E6E-BFE3-AB4B-4DC1-B10E610E1230}"/>
                 </a:ext>
               </a:extLst>
             </p:cNvPr>
@@ -9520,7 +9520,7 @@
           <p:cNvPr id="375" name="Google Shape;375;p18">
             <a:extLst>
               <a:ext uri="{FF2B5EF4-FFF2-40B4-BE49-F238E27FC236}">
-                <a16:creationId xmlns:a16="http://schemas.microsoft.com/office/drawing/2014/main" id="{FF7806ED-874A-1ABC-A259-1FD94A2A122B}"/>
+                <a16:creationId xmlns:a16="http://schemas.microsoft.com/office/drawing/2014/main" id="{3BD0ED18-1118-A536-4D4D-85DCCA5695F6}"/>
               </a:ext>
             </a:extLst>
           </p:cNvPr>
@@ -9529,7 +9529,7 @@
         </p:nvSpPr>
         <p:spPr>
           <a:xfrm>
-            <a:off x="4305039" y="3626785"/>
+            <a:off x="4305039" y="3833636"/>
             <a:ext cx="699955" cy="426638"/>
           </a:xfrm>
           <a:prstGeom prst="rect">
@@ -9575,7 +9575,7 @@
           <p:cNvPr id="376" name="Google Shape;376;p18">
             <a:extLst>
               <a:ext uri="{FF2B5EF4-FFF2-40B4-BE49-F238E27FC236}">
-                <a16:creationId xmlns:a16="http://schemas.microsoft.com/office/drawing/2014/main" id="{130DA79E-C186-FD7F-640F-E92E841F752F}"/>
+                <a16:creationId xmlns:a16="http://schemas.microsoft.com/office/drawing/2014/main" id="{2A6F8587-5553-954D-CAEE-A5442B8EFD26}"/>
               </a:ext>
             </a:extLst>
           </p:cNvPr>
@@ -9584,7 +9584,7 @@
         </p:nvSpPr>
         <p:spPr>
           <a:xfrm>
-            <a:off x="4419669" y="4234443"/>
+            <a:off x="4419669" y="4441294"/>
             <a:ext cx="541712" cy="426638"/>
           </a:xfrm>
           <a:prstGeom prst="rect">
@@ -9630,7 +9630,7 @@
           <p:cNvPr id="377" name="Google Shape;377;p18">
             <a:extLst>
               <a:ext uri="{FF2B5EF4-FFF2-40B4-BE49-F238E27FC236}">
-                <a16:creationId xmlns:a16="http://schemas.microsoft.com/office/drawing/2014/main" id="{AA8FDA29-795F-AC02-7E2C-3EB966E8126F}"/>
+                <a16:creationId xmlns:a16="http://schemas.microsoft.com/office/drawing/2014/main" id="{A71DCCDB-69A7-8B02-AB3B-F8FC5CF98DD1}"/>
               </a:ext>
             </a:extLst>
           </p:cNvPr>
@@ -9639,7 +9639,7 @@
         </p:nvGrpSpPr>
         <p:grpSpPr>
           <a:xfrm>
-            <a:off x="4419669" y="5447057"/>
+            <a:off x="4419669" y="5653908"/>
             <a:ext cx="469333" cy="455125"/>
             <a:chOff x="3021975" y="2389850"/>
             <a:chExt cx="307200" cy="297900"/>
@@ -9650,7 +9650,7 @@
             <p:cNvPr id="378" name="Google Shape;378;p18">
               <a:extLst>
                 <a:ext uri="{FF2B5EF4-FFF2-40B4-BE49-F238E27FC236}">
-                  <a16:creationId xmlns:a16="http://schemas.microsoft.com/office/drawing/2014/main" id="{6A49C134-ECEA-594B-8C57-94216002DB48}"/>
+                  <a16:creationId xmlns:a16="http://schemas.microsoft.com/office/drawing/2014/main" id="{71F08942-F734-19C2-DADD-0D324BF33C31}"/>
                 </a:ext>
               </a:extLst>
             </p:cNvPr>
@@ -9692,7 +9692,7 @@
             <p:cNvPr id="379" name="Google Shape;379;p18">
               <a:extLst>
                 <a:ext uri="{FF2B5EF4-FFF2-40B4-BE49-F238E27FC236}">
-                  <a16:creationId xmlns:a16="http://schemas.microsoft.com/office/drawing/2014/main" id="{53527EF2-6874-8D06-F183-E75547A99605}"/>
+                  <a16:creationId xmlns:a16="http://schemas.microsoft.com/office/drawing/2014/main" id="{33F6E28D-198C-95A6-2DE2-2F34769654C6}"/>
                 </a:ext>
               </a:extLst>
             </p:cNvPr>
@@ -9712,7 +9712,7 @@
               <p:cNvPr id="380" name="Google Shape;380;p18">
                 <a:extLst>
                   <a:ext uri="{FF2B5EF4-FFF2-40B4-BE49-F238E27FC236}">
-                    <a16:creationId xmlns:a16="http://schemas.microsoft.com/office/drawing/2014/main" id="{EC8E21CF-6678-6D5D-F8E7-66B09D1206A7}"/>
+                    <a16:creationId xmlns:a16="http://schemas.microsoft.com/office/drawing/2014/main" id="{65508DC0-E26A-6CA6-E704-3122E3724A80}"/>
                   </a:ext>
                 </a:extLst>
               </p:cNvPr>
@@ -9756,7 +9756,7 @@
               <p:cNvPr id="381" name="Google Shape;381;p18">
                 <a:extLst>
                   <a:ext uri="{FF2B5EF4-FFF2-40B4-BE49-F238E27FC236}">
-                    <a16:creationId xmlns:a16="http://schemas.microsoft.com/office/drawing/2014/main" id="{3940665D-0F9C-256D-0E96-5604AFC83398}"/>
+                    <a16:creationId xmlns:a16="http://schemas.microsoft.com/office/drawing/2014/main" id="{4D3DB35B-B194-9CAF-3411-6CB04949119A}"/>
                   </a:ext>
                 </a:extLst>
               </p:cNvPr>
@@ -9800,7 +9800,7 @@
               <p:cNvPr id="382" name="Google Shape;382;p18">
                 <a:extLst>
                   <a:ext uri="{FF2B5EF4-FFF2-40B4-BE49-F238E27FC236}">
-                    <a16:creationId xmlns:a16="http://schemas.microsoft.com/office/drawing/2014/main" id="{A76F4A21-622F-6965-6D22-7693EDB77EA3}"/>
+                    <a16:creationId xmlns:a16="http://schemas.microsoft.com/office/drawing/2014/main" id="{3F4D22C7-E510-2D01-A5E1-4ABB49A06E79}"/>
                   </a:ext>
                 </a:extLst>
               </p:cNvPr>
@@ -9832,7 +9832,7 @@
               <p:cNvPr id="383" name="Google Shape;383;p18">
                 <a:extLst>
                   <a:ext uri="{FF2B5EF4-FFF2-40B4-BE49-F238E27FC236}">
-                    <a16:creationId xmlns:a16="http://schemas.microsoft.com/office/drawing/2014/main" id="{DFF6E287-10F7-D08F-0618-B8C5E643B958}"/>
+                    <a16:creationId xmlns:a16="http://schemas.microsoft.com/office/drawing/2014/main" id="{869FC0AE-C16C-2F46-0EC8-BA10769954F2}"/>
                   </a:ext>
                 </a:extLst>
               </p:cNvPr>
@@ -9864,7 +9864,7 @@
               <p:cNvPr id="384" name="Google Shape;384;p18">
                 <a:extLst>
                   <a:ext uri="{FF2B5EF4-FFF2-40B4-BE49-F238E27FC236}">
-                    <a16:creationId xmlns:a16="http://schemas.microsoft.com/office/drawing/2014/main" id="{4BE65B04-8C12-ED47-F7B5-CA6255AAE226}"/>
+                    <a16:creationId xmlns:a16="http://schemas.microsoft.com/office/drawing/2014/main" id="{32F4A506-42C1-6676-6DF9-178B9189DF25}"/>
                   </a:ext>
                 </a:extLst>
               </p:cNvPr>
@@ -9908,7 +9908,7 @@
               <p:cNvPr id="385" name="Google Shape;385;p18">
                 <a:extLst>
                   <a:ext uri="{FF2B5EF4-FFF2-40B4-BE49-F238E27FC236}">
-                    <a16:creationId xmlns:a16="http://schemas.microsoft.com/office/drawing/2014/main" id="{6924CBE0-2794-C991-3D23-D1B31321A002}"/>
+                    <a16:creationId xmlns:a16="http://schemas.microsoft.com/office/drawing/2014/main" id="{BEDF321A-9EF5-3A2A-F77B-C72DA0804AB8}"/>
                   </a:ext>
                 </a:extLst>
               </p:cNvPr>
@@ -9940,7 +9940,7 @@
               <p:cNvPr id="386" name="Google Shape;386;p18">
                 <a:extLst>
                   <a:ext uri="{FF2B5EF4-FFF2-40B4-BE49-F238E27FC236}">
-                    <a16:creationId xmlns:a16="http://schemas.microsoft.com/office/drawing/2014/main" id="{4C3AF66B-0678-A42F-E3B9-34B2818B163C}"/>
+                    <a16:creationId xmlns:a16="http://schemas.microsoft.com/office/drawing/2014/main" id="{86BC4307-A8B3-EB81-9068-1058C2389C4D}"/>
                   </a:ext>
                 </a:extLst>
               </p:cNvPr>
@@ -9972,7 +9972,7 @@
               <p:cNvPr id="387" name="Google Shape;387;p18">
                 <a:extLst>
                   <a:ext uri="{FF2B5EF4-FFF2-40B4-BE49-F238E27FC236}">
-                    <a16:creationId xmlns:a16="http://schemas.microsoft.com/office/drawing/2014/main" id="{D6B55232-EF96-922B-0963-832B740BEAC8}"/>
+                    <a16:creationId xmlns:a16="http://schemas.microsoft.com/office/drawing/2014/main" id="{EE5ACB29-C0C3-302C-330C-30B9A0E4E807}"/>
                   </a:ext>
                 </a:extLst>
               </p:cNvPr>
@@ -10006,7 +10006,7 @@
           <p:cNvPr id="388" name="Google Shape;388;p18">
             <a:extLst>
               <a:ext uri="{FF2B5EF4-FFF2-40B4-BE49-F238E27FC236}">
-                <a16:creationId xmlns:a16="http://schemas.microsoft.com/office/drawing/2014/main" id="{B4BB37DD-AD67-FDEA-4EA8-FD0BA1BC5336}"/>
+                <a16:creationId xmlns:a16="http://schemas.microsoft.com/office/drawing/2014/main" id="{9A0CBAB1-4B51-47BD-F6E9-B4F6C02E211A}"/>
               </a:ext>
             </a:extLst>
           </p:cNvPr>
@@ -10015,7 +10015,7 @@
         </p:nvSpPr>
         <p:spPr>
           <a:xfrm>
-            <a:off x="4227782" y="4935847"/>
+            <a:off x="4227782" y="5142698"/>
             <a:ext cx="870375" cy="611304"/>
           </a:xfrm>
           <a:prstGeom prst="rect">
@@ -10062,7 +10062,7 @@
           <p:cNvPr id="389" name="Google Shape;389;p18">
             <a:extLst>
               <a:ext uri="{FF2B5EF4-FFF2-40B4-BE49-F238E27FC236}">
-                <a16:creationId xmlns:a16="http://schemas.microsoft.com/office/drawing/2014/main" id="{3120DA0A-EFB9-FE89-A01A-D31DA2EDB1EB}"/>
+                <a16:creationId xmlns:a16="http://schemas.microsoft.com/office/drawing/2014/main" id="{78ECE437-E8D0-9BFA-B193-5AB5158D3BD7}"/>
               </a:ext>
             </a:extLst>
           </p:cNvPr>
@@ -10073,7 +10073,7 @@
         </p:nvCxnSpPr>
         <p:spPr>
           <a:xfrm>
-            <a:off x="4645700" y="6064488"/>
+            <a:off x="4645700" y="6271339"/>
             <a:ext cx="0" cy="342265"/>
           </a:xfrm>
           <a:prstGeom prst="straightConnector1">
@@ -10096,7 +10096,7 @@
           <p:cNvPr id="390" name="Google Shape;390;p18">
             <a:extLst>
               <a:ext uri="{FF2B5EF4-FFF2-40B4-BE49-F238E27FC236}">
-                <a16:creationId xmlns:a16="http://schemas.microsoft.com/office/drawing/2014/main" id="{D480BEFF-7C88-200F-FBAB-22F382673B0F}"/>
+                <a16:creationId xmlns:a16="http://schemas.microsoft.com/office/drawing/2014/main" id="{BC559C0F-23E4-2A82-91EC-B39D3A464B8C}"/>
               </a:ext>
             </a:extLst>
           </p:cNvPr>
@@ -10105,7 +10105,7 @@
         </p:nvSpPr>
         <p:spPr>
           <a:xfrm>
-            <a:off x="4425267" y="6487978"/>
+            <a:off x="4425267" y="6694829"/>
             <a:ext cx="469333" cy="289208"/>
           </a:xfrm>
           <a:prstGeom prst="rect">
@@ -10138,7 +10138,7 @@
           <p:cNvPr id="394" name="Google Shape;394;p18">
             <a:extLst>
               <a:ext uri="{FF2B5EF4-FFF2-40B4-BE49-F238E27FC236}">
-                <a16:creationId xmlns:a16="http://schemas.microsoft.com/office/drawing/2014/main" id="{3E9B89F5-E767-AB39-3F65-4AF36C2AC3FE}"/>
+                <a16:creationId xmlns:a16="http://schemas.microsoft.com/office/drawing/2014/main" id="{E7448C42-070D-E355-74BE-305BF017E3BF}"/>
               </a:ext>
             </a:extLst>
           </p:cNvPr>
@@ -10147,7 +10147,7 @@
         </p:nvSpPr>
         <p:spPr>
           <a:xfrm>
-            <a:off x="5815821" y="2698484"/>
+            <a:off x="5815821" y="2905335"/>
             <a:ext cx="1886747" cy="289208"/>
           </a:xfrm>
           <a:prstGeom prst="rect">
@@ -10193,7 +10193,7 @@
           <p:cNvPr id="219" name="Google Shape;347;p18">
             <a:extLst>
               <a:ext uri="{FF2B5EF4-FFF2-40B4-BE49-F238E27FC236}">
-                <a16:creationId xmlns:a16="http://schemas.microsoft.com/office/drawing/2014/main" id="{5158ADF8-9331-4F53-A58A-62994C5DE592}"/>
+                <a16:creationId xmlns:a16="http://schemas.microsoft.com/office/drawing/2014/main" id="{D43ABD0A-DE48-9796-3B0B-E8A0BC81C535}"/>
               </a:ext>
             </a:extLst>
           </p:cNvPr>
@@ -10204,7 +10204,7 @@
         </p:nvSpPr>
         <p:spPr>
           <a:xfrm>
-            <a:off x="8123938" y="5062324"/>
+            <a:off x="8123938" y="5269175"/>
             <a:ext cx="287942" cy="259172"/>
           </a:xfrm>
           <a:prstGeom prst="rect">
@@ -10237,7 +10237,7 @@
           <p:cNvPr id="397" name="Google Shape;347;p18">
             <a:extLst>
               <a:ext uri="{FF2B5EF4-FFF2-40B4-BE49-F238E27FC236}">
-                <a16:creationId xmlns:a16="http://schemas.microsoft.com/office/drawing/2014/main" id="{47031FB1-475C-BB36-58FF-BA5AA8EEBE68}"/>
+                <a16:creationId xmlns:a16="http://schemas.microsoft.com/office/drawing/2014/main" id="{6D1D40C7-B0ED-478D-6716-6A1CD8A2C005}"/>
               </a:ext>
             </a:extLst>
           </p:cNvPr>
@@ -10248,7 +10248,7 @@
         </p:nvSpPr>
         <p:spPr>
           <a:xfrm>
-            <a:off x="8423975" y="5061518"/>
+            <a:off x="8423975" y="5268369"/>
             <a:ext cx="287942" cy="259172"/>
           </a:xfrm>
           <a:prstGeom prst="rect">
@@ -10281,7 +10281,7 @@
           <p:cNvPr id="398" name="Google Shape;347;p18">
             <a:extLst>
               <a:ext uri="{FF2B5EF4-FFF2-40B4-BE49-F238E27FC236}">
-                <a16:creationId xmlns:a16="http://schemas.microsoft.com/office/drawing/2014/main" id="{58DEB551-AB00-F63D-D5DB-4C6A57176F84}"/>
+                <a16:creationId xmlns:a16="http://schemas.microsoft.com/office/drawing/2014/main" id="{BF8DA687-C9B5-79A8-D98C-DE2014BCE219}"/>
               </a:ext>
             </a:extLst>
           </p:cNvPr>
@@ -10292,7 +10292,7 @@
         </p:nvSpPr>
         <p:spPr>
           <a:xfrm>
-            <a:off x="8724042" y="5062324"/>
+            <a:off x="8724042" y="5269175"/>
             <a:ext cx="287942" cy="259172"/>
           </a:xfrm>
           <a:prstGeom prst="rect">
@@ -10325,7 +10325,7 @@
           <p:cNvPr id="400" name="Google Shape;349;p18">
             <a:extLst>
               <a:ext uri="{FF2B5EF4-FFF2-40B4-BE49-F238E27FC236}">
-                <a16:creationId xmlns:a16="http://schemas.microsoft.com/office/drawing/2014/main" id="{C96A7D98-9E22-1FE2-5AB8-4771790CB593}"/>
+                <a16:creationId xmlns:a16="http://schemas.microsoft.com/office/drawing/2014/main" id="{31FFCA80-626A-325B-A8F7-6B0BA0E8FFFB}"/>
               </a:ext>
             </a:extLst>
           </p:cNvPr>
@@ -10334,7 +10334,7 @@
         </p:nvSpPr>
         <p:spPr>
           <a:xfrm>
-            <a:off x="8048117" y="5011325"/>
+            <a:off x="8048117" y="5218176"/>
             <a:ext cx="475871" cy="194398"/>
           </a:xfrm>
           <a:prstGeom prst="rect">
@@ -10377,7 +10377,7 @@
           <p:cNvPr id="401" name="Google Shape;349;p18">
             <a:extLst>
               <a:ext uri="{FF2B5EF4-FFF2-40B4-BE49-F238E27FC236}">
-                <a16:creationId xmlns:a16="http://schemas.microsoft.com/office/drawing/2014/main" id="{1669A03C-BB1E-FF05-3F64-9111C4AD6080}"/>
+                <a16:creationId xmlns:a16="http://schemas.microsoft.com/office/drawing/2014/main" id="{387E1638-5160-0122-225D-E52664DE85D9}"/>
               </a:ext>
             </a:extLst>
           </p:cNvPr>
@@ -10386,7 +10386,7 @@
         </p:nvSpPr>
         <p:spPr>
           <a:xfrm>
-            <a:off x="8344583" y="5010134"/>
+            <a:off x="8344583" y="5216985"/>
             <a:ext cx="475871" cy="194398"/>
           </a:xfrm>
           <a:prstGeom prst="rect">
@@ -10429,7 +10429,7 @@
           <p:cNvPr id="402" name="Google Shape;349;p18">
             <a:extLst>
               <a:ext uri="{FF2B5EF4-FFF2-40B4-BE49-F238E27FC236}">
-                <a16:creationId xmlns:a16="http://schemas.microsoft.com/office/drawing/2014/main" id="{DE3A130B-74D1-640C-A232-B8A25ECE78E9}"/>
+                <a16:creationId xmlns:a16="http://schemas.microsoft.com/office/drawing/2014/main" id="{9A76B127-03F8-9BCA-762D-A98DA23190E9}"/>
               </a:ext>
             </a:extLst>
           </p:cNvPr>
@@ -10438,7 +10438,7 @@
         </p:nvSpPr>
         <p:spPr>
           <a:xfrm>
-            <a:off x="8641049" y="5008943"/>
+            <a:off x="8641049" y="5215794"/>
             <a:ext cx="475871" cy="194398"/>
           </a:xfrm>
           <a:prstGeom prst="rect">
@@ -10481,7 +10481,7 @@
           <p:cNvPr id="502" name="Google Shape;292;p18">
             <a:extLst>
               <a:ext uri="{FF2B5EF4-FFF2-40B4-BE49-F238E27FC236}">
-                <a16:creationId xmlns:a16="http://schemas.microsoft.com/office/drawing/2014/main" id="{84A921B2-E24C-1DEF-A20B-07D60196B607}"/>
+                <a16:creationId xmlns:a16="http://schemas.microsoft.com/office/drawing/2014/main" id="{05CD089C-9EBE-C5E7-FDBB-F285602DBCCF}"/>
               </a:ext>
             </a:extLst>
           </p:cNvPr>
@@ -10490,7 +10490,7 @@
         </p:nvSpPr>
         <p:spPr>
           <a:xfrm>
-            <a:off x="5840053" y="6346726"/>
+            <a:off x="5840053" y="6553577"/>
             <a:ext cx="246674" cy="249601"/>
           </a:xfrm>
           <a:prstGeom prst="ellipse">
@@ -10525,7 +10525,7 @@
           <p:cNvPr id="503" name="Google Shape;293;p18">
             <a:extLst>
               <a:ext uri="{FF2B5EF4-FFF2-40B4-BE49-F238E27FC236}">
-                <a16:creationId xmlns:a16="http://schemas.microsoft.com/office/drawing/2014/main" id="{D53D1FA0-607F-3019-F982-6E8D3720F305}"/>
+                <a16:creationId xmlns:a16="http://schemas.microsoft.com/office/drawing/2014/main" id="{9CA4EBCA-F036-7C2D-7647-E3626ACEFB10}"/>
               </a:ext>
             </a:extLst>
           </p:cNvPr>
@@ -10534,7 +10534,7 @@
         </p:nvSpPr>
         <p:spPr>
           <a:xfrm>
-            <a:off x="5703039" y="6317265"/>
+            <a:off x="5703039" y="6530465"/>
             <a:ext cx="572742" cy="157250"/>
           </a:xfrm>
           <a:prstGeom prst="rect">
@@ -10574,7 +10574,7 @@
           <p:cNvPr id="505" name="Connector: Elbow 504">
             <a:extLst>
               <a:ext uri="{FF2B5EF4-FFF2-40B4-BE49-F238E27FC236}">
-                <a16:creationId xmlns:a16="http://schemas.microsoft.com/office/drawing/2014/main" id="{1A6A22F4-55FE-1DC1-C155-034E07913AA4}"/>
+                <a16:creationId xmlns:a16="http://schemas.microsoft.com/office/drawing/2014/main" id="{0315DF6B-44A6-D0B6-949D-AF7F45931DBA}"/>
               </a:ext>
             </a:extLst>
           </p:cNvPr>
@@ -10586,7 +10586,7 @@
         </p:nvCxnSpPr>
         <p:spPr>
           <a:xfrm>
-            <a:off x="4995414" y="4699000"/>
+            <a:off x="4995414" y="4905851"/>
             <a:ext cx="359040" cy="269553"/>
           </a:xfrm>
           <a:prstGeom prst="bentConnector3">
@@ -10616,7 +10616,7 @@
           <p:cNvPr id="4" name="Group 3">
             <a:extLst>
               <a:ext uri="{FF2B5EF4-FFF2-40B4-BE49-F238E27FC236}">
-                <a16:creationId xmlns:a16="http://schemas.microsoft.com/office/drawing/2014/main" id="{E553B7A0-DEA7-6B93-CFBF-71C9A11A89B2}"/>
+                <a16:creationId xmlns:a16="http://schemas.microsoft.com/office/drawing/2014/main" id="{C453A8DA-AA7D-C5F3-9D1F-B005C8863063}"/>
               </a:ext>
             </a:extLst>
           </p:cNvPr>
@@ -10625,7 +10625,7 @@
         </p:nvGrpSpPr>
         <p:grpSpPr>
           <a:xfrm>
-            <a:off x="4995415" y="5116116"/>
+            <a:off x="4995415" y="5322967"/>
             <a:ext cx="359040" cy="635397"/>
             <a:chOff x="4995414" y="5124450"/>
             <a:chExt cx="322797" cy="627063"/>
@@ -10636,7 +10636,7 @@
             <p:cNvPr id="508" name="Straight Connector 507">
               <a:extLst>
                 <a:ext uri="{FF2B5EF4-FFF2-40B4-BE49-F238E27FC236}">
-                  <a16:creationId xmlns:a16="http://schemas.microsoft.com/office/drawing/2014/main" id="{71ED58C0-7B7B-E4B6-4BA9-ED85B650DDAF}"/>
+                  <a16:creationId xmlns:a16="http://schemas.microsoft.com/office/drawing/2014/main" id="{9F447D56-5A5A-0B8C-10D2-3EA53EE5D64C}"/>
                 </a:ext>
               </a:extLst>
             </p:cNvPr>
@@ -10674,7 +10674,7 @@
             <p:cNvPr id="510" name="Straight Connector 509">
               <a:extLst>
                 <a:ext uri="{FF2B5EF4-FFF2-40B4-BE49-F238E27FC236}">
-                  <a16:creationId xmlns:a16="http://schemas.microsoft.com/office/drawing/2014/main" id="{E9857CE6-48B6-C9C2-65A6-14A23394E719}"/>
+                  <a16:creationId xmlns:a16="http://schemas.microsoft.com/office/drawing/2014/main" id="{9476FE5F-17DD-9A4A-31E5-F825D5078FAD}"/>
                 </a:ext>
               </a:extLst>
             </p:cNvPr>
@@ -10710,7 +10710,7 @@
             <p:cNvPr id="512" name="Straight Arrow Connector 511">
               <a:extLst>
                 <a:ext uri="{FF2B5EF4-FFF2-40B4-BE49-F238E27FC236}">
-                  <a16:creationId xmlns:a16="http://schemas.microsoft.com/office/drawing/2014/main" id="{2DEB9116-4CF8-27BA-56CE-C38B03A7EA85}"/>
+                  <a16:creationId xmlns:a16="http://schemas.microsoft.com/office/drawing/2014/main" id="{46CFA910-D0CC-398F-5C9B-570FAA0D4D84}"/>
                 </a:ext>
               </a:extLst>
             </p:cNvPr>
@@ -10752,7 +10752,7 @@
           <p:cNvPr id="13" name="Group 12">
             <a:extLst>
               <a:ext uri="{FF2B5EF4-FFF2-40B4-BE49-F238E27FC236}">
-                <a16:creationId xmlns:a16="http://schemas.microsoft.com/office/drawing/2014/main" id="{54C5A79E-25E5-D747-E979-83A35EA25CDA}"/>
+                <a16:creationId xmlns:a16="http://schemas.microsoft.com/office/drawing/2014/main" id="{D88AC189-326D-8FF8-FF80-EA564BAB1560}"/>
               </a:ext>
             </a:extLst>
           </p:cNvPr>
@@ -10761,7 +10761,7 @@
         </p:nvGrpSpPr>
         <p:grpSpPr>
           <a:xfrm>
-            <a:off x="4995414" y="4014788"/>
+            <a:off x="4995414" y="4221639"/>
             <a:ext cx="359040" cy="642937"/>
             <a:chOff x="4995414" y="4014788"/>
             <a:chExt cx="384401" cy="642937"/>
@@ -10772,7 +10772,7 @@
             <p:cNvPr id="6" name="Straight Connector 5">
               <a:extLst>
                 <a:ext uri="{FF2B5EF4-FFF2-40B4-BE49-F238E27FC236}">
-                  <a16:creationId xmlns:a16="http://schemas.microsoft.com/office/drawing/2014/main" id="{496CD3FB-F6F3-891A-F16D-9DE8B7BB4EA5}"/>
+                  <a16:creationId xmlns:a16="http://schemas.microsoft.com/office/drawing/2014/main" id="{EEA9001A-F9A2-8E30-5779-ADBC195599A1}"/>
                 </a:ext>
               </a:extLst>
             </p:cNvPr>
@@ -10810,7 +10810,7 @@
             <p:cNvPr id="8" name="Straight Connector 7">
               <a:extLst>
                 <a:ext uri="{FF2B5EF4-FFF2-40B4-BE49-F238E27FC236}">
-                  <a16:creationId xmlns:a16="http://schemas.microsoft.com/office/drawing/2014/main" id="{F150A26B-8108-E785-9AD7-525D46A71E9B}"/>
+                  <a16:creationId xmlns:a16="http://schemas.microsoft.com/office/drawing/2014/main" id="{C6A13696-C037-95A8-F09D-CE71736EB039}"/>
                 </a:ext>
               </a:extLst>
             </p:cNvPr>
@@ -10846,7 +10846,7 @@
             <p:cNvPr id="10" name="Straight Arrow Connector 9">
               <a:extLst>
                 <a:ext uri="{FF2B5EF4-FFF2-40B4-BE49-F238E27FC236}">
-                  <a16:creationId xmlns:a16="http://schemas.microsoft.com/office/drawing/2014/main" id="{D772DA95-879F-707D-E3F4-281C06E773AC}"/>
+                  <a16:creationId xmlns:a16="http://schemas.microsoft.com/office/drawing/2014/main" id="{F1FF3EEF-94B5-73D5-EAC6-211F0EF4AFC2}"/>
                 </a:ext>
               </a:extLst>
             </p:cNvPr>
@@ -10891,7 +10891,7 @@
           <p:cNvPr id="11" name="Google Shape;342;p18">
             <a:extLst>
               <a:ext uri="{FF2B5EF4-FFF2-40B4-BE49-F238E27FC236}">
-                <a16:creationId xmlns:a16="http://schemas.microsoft.com/office/drawing/2014/main" id="{6D0E33BC-9A85-1338-6695-02AA299FE4D1}"/>
+                <a16:creationId xmlns:a16="http://schemas.microsoft.com/office/drawing/2014/main" id="{6D4C0A6F-471B-10F9-BF5C-C7731D6D019E}"/>
               </a:ext>
             </a:extLst>
           </p:cNvPr>
@@ -10900,7 +10900,7 @@
         </p:nvSpPr>
         <p:spPr>
           <a:xfrm>
-            <a:off x="6913076" y="5603947"/>
+            <a:off x="6913076" y="5810798"/>
             <a:ext cx="204417" cy="175083"/>
           </a:xfrm>
           <a:prstGeom prst="wedgeRectCallout">
@@ -10938,7 +10938,7 @@
           <p:cNvPr id="12" name="Google Shape;342;p18">
             <a:extLst>
               <a:ext uri="{FF2B5EF4-FFF2-40B4-BE49-F238E27FC236}">
-                <a16:creationId xmlns:a16="http://schemas.microsoft.com/office/drawing/2014/main" id="{635C6A7A-D351-10A6-64FD-3FD5F6B03C6D}"/>
+                <a16:creationId xmlns:a16="http://schemas.microsoft.com/office/drawing/2014/main" id="{D68B9E22-6A55-3D1B-6CE4-7C5881F80AC1}"/>
               </a:ext>
             </a:extLst>
           </p:cNvPr>
@@ -10947,7 +10947,7 @@
         </p:nvSpPr>
         <p:spPr>
           <a:xfrm>
-            <a:off x="7301918" y="5596454"/>
+            <a:off x="7301918" y="5803305"/>
             <a:ext cx="204417" cy="175083"/>
           </a:xfrm>
           <a:prstGeom prst="wedgeRectCallout">
@@ -10985,7 +10985,7 @@
           <p:cNvPr id="14" name="Google Shape;342;p18">
             <a:extLst>
               <a:ext uri="{FF2B5EF4-FFF2-40B4-BE49-F238E27FC236}">
-                <a16:creationId xmlns:a16="http://schemas.microsoft.com/office/drawing/2014/main" id="{A38AF74F-2BCC-6015-7DE1-E37FEA80AE13}"/>
+                <a16:creationId xmlns:a16="http://schemas.microsoft.com/office/drawing/2014/main" id="{C933F6EC-6794-DF6E-40C6-BD1BB117ED63}"/>
               </a:ext>
             </a:extLst>
           </p:cNvPr>
@@ -10994,7 +10994,7 @@
         </p:nvSpPr>
         <p:spPr>
           <a:xfrm>
-            <a:off x="6853267" y="4366648"/>
+            <a:off x="6853267" y="4573499"/>
             <a:ext cx="204417" cy="175083"/>
           </a:xfrm>
           <a:prstGeom prst="wedgeRectCallout">
@@ -11030,7 +11030,7 @@
           <p:cNvPr id="15" name="Google Shape;342;p18">
             <a:extLst>
               <a:ext uri="{FF2B5EF4-FFF2-40B4-BE49-F238E27FC236}">
-                <a16:creationId xmlns:a16="http://schemas.microsoft.com/office/drawing/2014/main" id="{58ED08B0-65E5-0FEC-03B0-E5CA9B84FDB0}"/>
+                <a16:creationId xmlns:a16="http://schemas.microsoft.com/office/drawing/2014/main" id="{69DFF445-27F3-366D-E6C5-9A69E89C43B8}"/>
               </a:ext>
             </a:extLst>
           </p:cNvPr>
@@ -11039,7 +11039,7 @@
         </p:nvSpPr>
         <p:spPr>
           <a:xfrm>
-            <a:off x="8159758" y="8535909"/>
+            <a:off x="8159758" y="8742760"/>
             <a:ext cx="204417" cy="175083"/>
           </a:xfrm>
           <a:prstGeom prst="wedgeRectCallout">
@@ -11077,7 +11077,7 @@
           <p:cNvPr id="16" name="Google Shape;342;p18">
             <a:extLst>
               <a:ext uri="{FF2B5EF4-FFF2-40B4-BE49-F238E27FC236}">
-                <a16:creationId xmlns:a16="http://schemas.microsoft.com/office/drawing/2014/main" id="{F2BEC4D0-27FF-6CE6-2E86-F16F206F2AAA}"/>
+                <a16:creationId xmlns:a16="http://schemas.microsoft.com/office/drawing/2014/main" id="{79BBD1F8-7718-5868-B859-F6E575928F9D}"/>
               </a:ext>
             </a:extLst>
           </p:cNvPr>
@@ -11086,7 +11086,7 @@
         </p:nvSpPr>
         <p:spPr>
           <a:xfrm>
-            <a:off x="9140222" y="8531790"/>
+            <a:off x="9140222" y="8738641"/>
             <a:ext cx="204417" cy="175083"/>
           </a:xfrm>
           <a:prstGeom prst="wedgeRectCallout">
@@ -11124,7 +11124,7 @@
           <p:cNvPr id="17" name="Google Shape;342;p18">
             <a:extLst>
               <a:ext uri="{FF2B5EF4-FFF2-40B4-BE49-F238E27FC236}">
-                <a16:creationId xmlns:a16="http://schemas.microsoft.com/office/drawing/2014/main" id="{3585022B-4A25-1DC1-5BD4-F8956061B63B}"/>
+                <a16:creationId xmlns:a16="http://schemas.microsoft.com/office/drawing/2014/main" id="{37922E67-88C3-CCB6-4B44-26C60C6F1D2A}"/>
               </a:ext>
             </a:extLst>
           </p:cNvPr>
@@ -11133,7 +11133,7 @@
         </p:nvSpPr>
         <p:spPr>
           <a:xfrm>
-            <a:off x="5008114" y="8722940"/>
+            <a:off x="5008114" y="8929791"/>
             <a:ext cx="204417" cy="175083"/>
           </a:xfrm>
           <a:prstGeom prst="wedgeRectCallout">
@@ -11171,7 +11171,7 @@
           <p:cNvPr id="18" name="Google Shape;342;p18">
             <a:extLst>
               <a:ext uri="{FF2B5EF4-FFF2-40B4-BE49-F238E27FC236}">
-                <a16:creationId xmlns:a16="http://schemas.microsoft.com/office/drawing/2014/main" id="{08303B46-72F8-1598-28AA-2B0858FA77A7}"/>
+                <a16:creationId xmlns:a16="http://schemas.microsoft.com/office/drawing/2014/main" id="{5BC00508-6E51-B041-2D02-8B5BEF970E63}"/>
               </a:ext>
             </a:extLst>
           </p:cNvPr>
@@ -11180,7 +11180,7 @@
         </p:nvSpPr>
         <p:spPr>
           <a:xfrm>
-            <a:off x="6198486" y="7808399"/>
+            <a:off x="6198486" y="8015250"/>
             <a:ext cx="204417" cy="175083"/>
           </a:xfrm>
           <a:prstGeom prst="wedgeRectCallout">
@@ -11216,7 +11216,7 @@
           <p:cNvPr id="21" name="Google Shape;389;p18">
             <a:extLst>
               <a:ext uri="{FF2B5EF4-FFF2-40B4-BE49-F238E27FC236}">
-                <a16:creationId xmlns:a16="http://schemas.microsoft.com/office/drawing/2014/main" id="{3DFFFAE9-E568-471C-0479-24545A8342AB}"/>
+                <a16:creationId xmlns:a16="http://schemas.microsoft.com/office/drawing/2014/main" id="{34DBFFD7-30AF-3484-3364-D11988091257}"/>
               </a:ext>
             </a:extLst>
           </p:cNvPr>
@@ -11227,7 +11227,7 @@
         </p:nvCxnSpPr>
         <p:spPr>
           <a:xfrm>
-            <a:off x="864275" y="7243816"/>
+            <a:off x="864275" y="7450667"/>
             <a:ext cx="0" cy="342265"/>
           </a:xfrm>
           <a:prstGeom prst="straightConnector1">
@@ -11250,7 +11250,7 @@
           <p:cNvPr id="516" name="Google Shape;212;p18">
             <a:extLst>
               <a:ext uri="{FF2B5EF4-FFF2-40B4-BE49-F238E27FC236}">
-                <a16:creationId xmlns:a16="http://schemas.microsoft.com/office/drawing/2014/main" id="{62363C77-72EA-35DB-21B7-521401481CC7}"/>
+                <a16:creationId xmlns:a16="http://schemas.microsoft.com/office/drawing/2014/main" id="{7AF53600-3177-FF4B-E023-4FFCA3621AC4}"/>
               </a:ext>
             </a:extLst>
           </p:cNvPr>
@@ -11261,7 +11261,7 @@
         </p:nvCxnSpPr>
         <p:spPr>
           <a:xfrm rot="10800000">
-            <a:off x="10806713" y="9657332"/>
+            <a:off x="10806713" y="9864183"/>
             <a:ext cx="204417" cy="118708"/>
           </a:xfrm>
           <a:prstGeom prst="straightConnector1">
@@ -11284,7 +11284,7 @@
           <p:cNvPr id="517" name="Google Shape;213;p18">
             <a:extLst>
               <a:ext uri="{FF2B5EF4-FFF2-40B4-BE49-F238E27FC236}">
-                <a16:creationId xmlns:a16="http://schemas.microsoft.com/office/drawing/2014/main" id="{0302D61E-8AC6-B77C-01ED-38120BB09432}"/>
+                <a16:creationId xmlns:a16="http://schemas.microsoft.com/office/drawing/2014/main" id="{5CB4265C-663D-3D7A-BA0C-C6B30DFCE51A}"/>
               </a:ext>
             </a:extLst>
           </p:cNvPr>
@@ -11295,7 +11295,7 @@
         </p:nvCxnSpPr>
         <p:spPr>
           <a:xfrm rot="10800000">
-            <a:off x="10800827" y="9552934"/>
+            <a:off x="10800827" y="9759785"/>
             <a:ext cx="78375" cy="132000"/>
           </a:xfrm>
           <a:prstGeom prst="straightConnector1">
@@ -11318,7 +11318,7 @@
           <p:cNvPr id="518" name="Google Shape;214;p18">
             <a:extLst>
               <a:ext uri="{FF2B5EF4-FFF2-40B4-BE49-F238E27FC236}">
-                <a16:creationId xmlns:a16="http://schemas.microsoft.com/office/drawing/2014/main" id="{0FC37CA0-3868-F635-6363-3492A4CC1850}"/>
+                <a16:creationId xmlns:a16="http://schemas.microsoft.com/office/drawing/2014/main" id="{8E7FBDC8-64A1-0F11-950B-D6CEA2952A79}"/>
               </a:ext>
             </a:extLst>
           </p:cNvPr>
@@ -11329,7 +11329,7 @@
         </p:nvCxnSpPr>
         <p:spPr>
           <a:xfrm flipH="1">
-            <a:off x="10875492" y="9518435"/>
+            <a:off x="10875492" y="9725286"/>
             <a:ext cx="327250" cy="160417"/>
           </a:xfrm>
           <a:prstGeom prst="straightConnector1">
@@ -11352,7 +11352,7 @@
           <p:cNvPr id="519" name="Google Shape;215;p18">
             <a:extLst>
               <a:ext uri="{FF2B5EF4-FFF2-40B4-BE49-F238E27FC236}">
-                <a16:creationId xmlns:a16="http://schemas.microsoft.com/office/drawing/2014/main" id="{B5838D4D-F03E-DC13-1857-5165467B87F1}"/>
+                <a16:creationId xmlns:a16="http://schemas.microsoft.com/office/drawing/2014/main" id="{F1186A45-F4D9-4B50-398F-BABFA2C21270}"/>
               </a:ext>
             </a:extLst>
           </p:cNvPr>
@@ -11361,7 +11361,7 @@
         </p:nvSpPr>
         <p:spPr>
           <a:xfrm>
-            <a:off x="10851819" y="9637116"/>
+            <a:off x="10851819" y="9843967"/>
             <a:ext cx="69667" cy="69667"/>
           </a:xfrm>
           <a:prstGeom prst="ellipse">
@@ -11396,7 +11396,7 @@
           <p:cNvPr id="520" name="Google Shape;246;p18">
             <a:extLst>
               <a:ext uri="{FF2B5EF4-FFF2-40B4-BE49-F238E27FC236}">
-                <a16:creationId xmlns:a16="http://schemas.microsoft.com/office/drawing/2014/main" id="{9E61FAE0-000E-2E3F-DE5E-F0955D697D8C}"/>
+                <a16:creationId xmlns:a16="http://schemas.microsoft.com/office/drawing/2014/main" id="{5005E5E7-BA4C-063E-2EF9-DA9BAE2A9817}"/>
               </a:ext>
             </a:extLst>
           </p:cNvPr>
@@ -11413,7 +11413,7 @@
         </p:blipFill>
         <p:spPr>
           <a:xfrm>
-            <a:off x="9476869" y="6357242"/>
+            <a:off x="9476869" y="6564093"/>
             <a:ext cx="3884579" cy="470250"/>
           </a:xfrm>
           <a:prstGeom prst="rect">
@@ -11430,7 +11430,7 @@
           <p:cNvPr id="521" name="Google Shape;247;p18">
             <a:extLst>
               <a:ext uri="{FF2B5EF4-FFF2-40B4-BE49-F238E27FC236}">
-                <a16:creationId xmlns:a16="http://schemas.microsoft.com/office/drawing/2014/main" id="{BFD60204-C832-078C-88BC-34BAA4BC0705}"/>
+                <a16:creationId xmlns:a16="http://schemas.microsoft.com/office/drawing/2014/main" id="{AA599406-A477-1816-2B48-C43BC2AFB7AA}"/>
               </a:ext>
             </a:extLst>
           </p:cNvPr>
@@ -11439,7 +11439,7 @@
         </p:nvSpPr>
         <p:spPr>
           <a:xfrm>
-            <a:off x="13107900" y="6364735"/>
+            <a:off x="13107900" y="6571586"/>
             <a:ext cx="843280" cy="466748"/>
           </a:xfrm>
           <a:prstGeom prst="rect">
@@ -11485,7 +11485,7 @@
           <p:cNvPr id="522" name="Google Shape;248;p18">
             <a:extLst>
               <a:ext uri="{FF2B5EF4-FFF2-40B4-BE49-F238E27FC236}">
-                <a16:creationId xmlns:a16="http://schemas.microsoft.com/office/drawing/2014/main" id="{95CE58B1-F1FE-8AAB-B447-30034EC796CB}"/>
+                <a16:creationId xmlns:a16="http://schemas.microsoft.com/office/drawing/2014/main" id="{99F08044-7AB1-00DF-9053-C88A496B78C8}"/>
               </a:ext>
             </a:extLst>
           </p:cNvPr>
@@ -11502,7 +11502,7 @@
         </p:blipFill>
         <p:spPr>
           <a:xfrm>
-            <a:off x="9476869" y="6729337"/>
+            <a:off x="9476869" y="6936188"/>
             <a:ext cx="809211" cy="470250"/>
           </a:xfrm>
           <a:prstGeom prst="rect">
@@ -11519,7 +11519,7 @@
           <p:cNvPr id="523" name="Google Shape;249;p18">
             <a:extLst>
               <a:ext uri="{FF2B5EF4-FFF2-40B4-BE49-F238E27FC236}">
-                <a16:creationId xmlns:a16="http://schemas.microsoft.com/office/drawing/2014/main" id="{3C222691-8FA6-D98F-3296-BF9CC4C4E950}"/>
+                <a16:creationId xmlns:a16="http://schemas.microsoft.com/office/drawing/2014/main" id="{5811298F-E7BD-04C9-7145-DA41FA37B6D4}"/>
               </a:ext>
             </a:extLst>
           </p:cNvPr>
@@ -11530,7 +11530,7 @@
         </p:nvCxnSpPr>
         <p:spPr>
           <a:xfrm>
-            <a:off x="9612954" y="7273091"/>
+            <a:off x="9612954" y="7479942"/>
             <a:ext cx="547919" cy="2275"/>
           </a:xfrm>
           <a:prstGeom prst="straightConnector1">
@@ -11553,7 +11553,7 @@
           <p:cNvPr id="524" name="Google Shape;250;p18">
             <a:extLst>
               <a:ext uri="{FF2B5EF4-FFF2-40B4-BE49-F238E27FC236}">
-                <a16:creationId xmlns:a16="http://schemas.microsoft.com/office/drawing/2014/main" id="{3EE75C50-5887-C912-7DBE-D5173B54A387}"/>
+                <a16:creationId xmlns:a16="http://schemas.microsoft.com/office/drawing/2014/main" id="{6409834D-2792-B7B2-C36A-9337BDEE51C8}"/>
               </a:ext>
             </a:extLst>
           </p:cNvPr>
@@ -11562,7 +11562,7 @@
         </p:nvSpPr>
         <p:spPr>
           <a:xfrm>
-            <a:off x="9615396" y="7323207"/>
+            <a:off x="9615396" y="7530058"/>
             <a:ext cx="546544" cy="466748"/>
           </a:xfrm>
           <a:prstGeom prst="rect">
@@ -11608,7 +11608,7 @@
           <p:cNvPr id="525" name="Google Shape;251;p18">
             <a:extLst>
               <a:ext uri="{FF2B5EF4-FFF2-40B4-BE49-F238E27FC236}">
-                <a16:creationId xmlns:a16="http://schemas.microsoft.com/office/drawing/2014/main" id="{3610051F-AD81-6F6A-F191-20C0ACECEE7E}"/>
+                <a16:creationId xmlns:a16="http://schemas.microsoft.com/office/drawing/2014/main" id="{33E2B704-9A4E-9C9A-6776-AB667665DF63}"/>
               </a:ext>
             </a:extLst>
           </p:cNvPr>
@@ -11625,7 +11625,7 @@
         </p:blipFill>
         <p:spPr>
           <a:xfrm>
-            <a:off x="9498598" y="7233756"/>
+            <a:off x="9498598" y="7440607"/>
             <a:ext cx="777249" cy="347527"/>
           </a:xfrm>
           <a:prstGeom prst="rect">
@@ -11642,7 +11642,7 @@
           <p:cNvPr id="526" name="Google Shape;253;p18">
             <a:extLst>
               <a:ext uri="{FF2B5EF4-FFF2-40B4-BE49-F238E27FC236}">
-                <a16:creationId xmlns:a16="http://schemas.microsoft.com/office/drawing/2014/main" id="{A93CCA87-EB3D-72A6-240E-87E1B9DD4558}"/>
+                <a16:creationId xmlns:a16="http://schemas.microsoft.com/office/drawing/2014/main" id="{956B46F7-F0F0-1DC5-CAA3-F66699CAED12}"/>
               </a:ext>
             </a:extLst>
           </p:cNvPr>
@@ -11651,7 +11651,7 @@
         </p:nvSpPr>
         <p:spPr>
           <a:xfrm>
-            <a:off x="10072720" y="6729029"/>
+            <a:off x="10072720" y="6935880"/>
             <a:ext cx="1416856" cy="466748"/>
           </a:xfrm>
           <a:prstGeom prst="rect">
@@ -11697,7 +11697,7 @@
           <p:cNvPr id="527" name="Google Shape;254;p18">
             <a:extLst>
               <a:ext uri="{FF2B5EF4-FFF2-40B4-BE49-F238E27FC236}">
-                <a16:creationId xmlns:a16="http://schemas.microsoft.com/office/drawing/2014/main" id="{58540324-FC1E-E693-1539-DD522F1C72F1}"/>
+                <a16:creationId xmlns:a16="http://schemas.microsoft.com/office/drawing/2014/main" id="{B8A70102-48BF-ED10-4323-1D35931E9023}"/>
               </a:ext>
             </a:extLst>
           </p:cNvPr>
@@ -11706,7 +11706,7 @@
         </p:nvSpPr>
         <p:spPr>
           <a:xfrm>
-            <a:off x="11295671" y="6727664"/>
+            <a:off x="11295671" y="6934515"/>
             <a:ext cx="678035" cy="466748"/>
           </a:xfrm>
           <a:prstGeom prst="rect">
@@ -11752,7 +11752,7 @@
           <p:cNvPr id="528" name="Google Shape;255;p18">
             <a:extLst>
               <a:ext uri="{FF2B5EF4-FFF2-40B4-BE49-F238E27FC236}">
-                <a16:creationId xmlns:a16="http://schemas.microsoft.com/office/drawing/2014/main" id="{91A9887A-75D8-9176-E50D-0BF5F2DD7A1B}"/>
+                <a16:creationId xmlns:a16="http://schemas.microsoft.com/office/drawing/2014/main" id="{45D03630-A303-80F1-3E40-9223C4D5E37B}"/>
               </a:ext>
             </a:extLst>
           </p:cNvPr>
@@ -11761,7 +11761,7 @@
         </p:nvSpPr>
         <p:spPr>
           <a:xfrm>
-            <a:off x="11987647" y="6727350"/>
+            <a:off x="11987647" y="6934201"/>
             <a:ext cx="537849" cy="466748"/>
           </a:xfrm>
           <a:prstGeom prst="rect">
@@ -11807,7 +11807,7 @@
           <p:cNvPr id="529" name="Google Shape;292;p18">
             <a:extLst>
               <a:ext uri="{FF2B5EF4-FFF2-40B4-BE49-F238E27FC236}">
-                <a16:creationId xmlns:a16="http://schemas.microsoft.com/office/drawing/2014/main" id="{022D0C62-3FAA-E0DD-77BA-9D8B3829820C}"/>
+                <a16:creationId xmlns:a16="http://schemas.microsoft.com/office/drawing/2014/main" id="{C6C7F4FB-CE82-9B32-5282-6FF30C329E28}"/>
               </a:ext>
             </a:extLst>
           </p:cNvPr>
@@ -11816,7 +11816,7 @@
         </p:nvSpPr>
         <p:spPr>
           <a:xfrm>
-            <a:off x="11755733" y="6825276"/>
+            <a:off x="11755733" y="7032127"/>
             <a:ext cx="246674" cy="249601"/>
           </a:xfrm>
           <a:prstGeom prst="ellipse">
@@ -11851,7 +11851,7 @@
           <p:cNvPr id="530" name="Google Shape;293;p18">
             <a:extLst>
               <a:ext uri="{FF2B5EF4-FFF2-40B4-BE49-F238E27FC236}">
-                <a16:creationId xmlns:a16="http://schemas.microsoft.com/office/drawing/2014/main" id="{0165C04D-A063-E820-888A-0AB790902F45}"/>
+                <a16:creationId xmlns:a16="http://schemas.microsoft.com/office/drawing/2014/main" id="{18F872E4-26CC-614C-1CA2-780D5AAE37CE}"/>
               </a:ext>
             </a:extLst>
           </p:cNvPr>
@@ -11860,7 +11860,7 @@
         </p:nvSpPr>
         <p:spPr>
           <a:xfrm>
-            <a:off x="11623088" y="6798989"/>
+            <a:off x="11623088" y="7005840"/>
             <a:ext cx="537849" cy="157250"/>
           </a:xfrm>
           <a:prstGeom prst="rect">
@@ -11900,7 +11900,7 @@
           <p:cNvPr id="531" name="Google Shape;296;p18">
             <a:extLst>
               <a:ext uri="{FF2B5EF4-FFF2-40B4-BE49-F238E27FC236}">
-                <a16:creationId xmlns:a16="http://schemas.microsoft.com/office/drawing/2014/main" id="{3AC020D3-81B6-0388-792D-5C5964705F0C}"/>
+                <a16:creationId xmlns:a16="http://schemas.microsoft.com/office/drawing/2014/main" id="{C5CAD4E7-97E1-C8AB-E15C-990A8E9A1D9E}"/>
               </a:ext>
             </a:extLst>
           </p:cNvPr>
@@ -11911,7 +11911,7 @@
         </p:nvCxnSpPr>
         <p:spPr>
           <a:xfrm rot="10800000">
-            <a:off x="9854524" y="8764317"/>
+            <a:off x="9854524" y="8971168"/>
             <a:ext cx="0" cy="1392417"/>
           </a:xfrm>
           <a:prstGeom prst="straightConnector1">
@@ -11934,7 +11934,7 @@
           <p:cNvPr id="532" name="Google Shape;297;p18">
             <a:extLst>
               <a:ext uri="{FF2B5EF4-FFF2-40B4-BE49-F238E27FC236}">
-                <a16:creationId xmlns:a16="http://schemas.microsoft.com/office/drawing/2014/main" id="{095255E6-D278-22EF-199C-F17C89C5A605}"/>
+                <a16:creationId xmlns:a16="http://schemas.microsoft.com/office/drawing/2014/main" id="{F0B877FC-FB59-F08E-C70D-166F19996B03}"/>
               </a:ext>
             </a:extLst>
           </p:cNvPr>
@@ -11945,7 +11945,7 @@
         </p:nvCxnSpPr>
         <p:spPr>
           <a:xfrm flipV="1">
-            <a:off x="9853450" y="10156734"/>
+            <a:off x="9853450" y="10363585"/>
             <a:ext cx="1484490" cy="2"/>
           </a:xfrm>
           <a:prstGeom prst="straightConnector1">
@@ -11968,7 +11968,7 @@
           <p:cNvPr id="533" name="Google Shape;298;p18">
             <a:extLst>
               <a:ext uri="{FF2B5EF4-FFF2-40B4-BE49-F238E27FC236}">
-                <a16:creationId xmlns:a16="http://schemas.microsoft.com/office/drawing/2014/main" id="{8646DE19-8D73-B5EA-D195-DD22A30E749B}"/>
+                <a16:creationId xmlns:a16="http://schemas.microsoft.com/office/drawing/2014/main" id="{3ED79546-819A-E40F-653F-79C7E536D309}"/>
               </a:ext>
             </a:extLst>
           </p:cNvPr>
@@ -11979,7 +11979,7 @@
         </p:nvCxnSpPr>
         <p:spPr>
           <a:xfrm rot="10800000" flipH="1">
-            <a:off x="9877216" y="9612570"/>
+            <a:off x="9877216" y="9819421"/>
             <a:ext cx="260792" cy="518375"/>
           </a:xfrm>
           <a:prstGeom prst="straightConnector1">
@@ -12002,7 +12002,7 @@
           <p:cNvPr id="534" name="Google Shape;299;p18">
             <a:extLst>
               <a:ext uri="{FF2B5EF4-FFF2-40B4-BE49-F238E27FC236}">
-                <a16:creationId xmlns:a16="http://schemas.microsoft.com/office/drawing/2014/main" id="{B0CAEC4E-57E1-B8B6-4C14-0FF9582C47FB}"/>
+                <a16:creationId xmlns:a16="http://schemas.microsoft.com/office/drawing/2014/main" id="{5975A300-58E8-5916-937B-C809A1FEF7B8}"/>
               </a:ext>
             </a:extLst>
           </p:cNvPr>
@@ -12013,7 +12013,7 @@
         </p:nvCxnSpPr>
         <p:spPr>
           <a:xfrm>
-            <a:off x="10141071" y="9619000"/>
+            <a:off x="10141071" y="9825851"/>
             <a:ext cx="245208" cy="245208"/>
           </a:xfrm>
           <a:prstGeom prst="straightConnector1">
@@ -12036,7 +12036,7 @@
           <p:cNvPr id="535" name="Google Shape;300;p18">
             <a:extLst>
               <a:ext uri="{FF2B5EF4-FFF2-40B4-BE49-F238E27FC236}">
-                <a16:creationId xmlns:a16="http://schemas.microsoft.com/office/drawing/2014/main" id="{67DAAA6E-F98E-C67A-5EC5-AB4C22A989A1}"/>
+                <a16:creationId xmlns:a16="http://schemas.microsoft.com/office/drawing/2014/main" id="{8E33F829-30B2-5BB7-5ADF-47CAD73D59E1}"/>
               </a:ext>
             </a:extLst>
           </p:cNvPr>
@@ -12047,7 +12047,7 @@
         </p:nvCxnSpPr>
         <p:spPr>
           <a:xfrm rot="10800000" flipH="1">
-            <a:off x="10389217" y="9741783"/>
+            <a:off x="10389217" y="9948634"/>
             <a:ext cx="226417" cy="112750"/>
           </a:xfrm>
           <a:prstGeom prst="straightConnector1">
@@ -12070,7 +12070,7 @@
           <p:cNvPr id="536" name="Google Shape;301;p18">
             <a:extLst>
               <a:ext uri="{FF2B5EF4-FFF2-40B4-BE49-F238E27FC236}">
-                <a16:creationId xmlns:a16="http://schemas.microsoft.com/office/drawing/2014/main" id="{59C9756D-6A44-A340-1053-1FD9FA1B755E}"/>
+                <a16:creationId xmlns:a16="http://schemas.microsoft.com/office/drawing/2014/main" id="{D5D55F28-B224-3814-BA1A-AE362DBAF830}"/>
               </a:ext>
             </a:extLst>
           </p:cNvPr>
@@ -12081,7 +12081,7 @@
         </p:nvCxnSpPr>
         <p:spPr>
           <a:xfrm rot="10800000" flipH="1">
-            <a:off x="10615571" y="9537735"/>
+            <a:off x="10615571" y="9744586"/>
             <a:ext cx="179208" cy="203958"/>
           </a:xfrm>
           <a:prstGeom prst="straightConnector1">
@@ -12104,7 +12104,7 @@
           <p:cNvPr id="537" name="Google Shape;302;p18">
             <a:extLst>
               <a:ext uri="{FF2B5EF4-FFF2-40B4-BE49-F238E27FC236}">
-                <a16:creationId xmlns:a16="http://schemas.microsoft.com/office/drawing/2014/main" id="{E3F94C87-E411-CFBE-05F8-75D607BF1B67}"/>
+                <a16:creationId xmlns:a16="http://schemas.microsoft.com/office/drawing/2014/main" id="{7B52D890-F0B2-190C-147E-8A9B7E70F531}"/>
               </a:ext>
             </a:extLst>
           </p:cNvPr>
@@ -12115,7 +12115,7 @@
         </p:nvCxnSpPr>
         <p:spPr>
           <a:xfrm rot="10800000" flipH="1">
-            <a:off x="9882452" y="9804174"/>
+            <a:off x="9882452" y="10011025"/>
             <a:ext cx="292875" cy="322208"/>
           </a:xfrm>
           <a:prstGeom prst="straightConnector1">
@@ -12138,7 +12138,7 @@
           <p:cNvPr id="538" name="Google Shape;303;p18">
             <a:extLst>
               <a:ext uri="{FF2B5EF4-FFF2-40B4-BE49-F238E27FC236}">
-                <a16:creationId xmlns:a16="http://schemas.microsoft.com/office/drawing/2014/main" id="{9BD614F5-7742-B00F-1D02-1D014BF1E80F}"/>
+                <a16:creationId xmlns:a16="http://schemas.microsoft.com/office/drawing/2014/main" id="{AAA3428A-B1A9-FE38-BF52-972CEFF8D938}"/>
               </a:ext>
             </a:extLst>
           </p:cNvPr>
@@ -12149,7 +12149,7 @@
         </p:nvCxnSpPr>
         <p:spPr>
           <a:xfrm rot="10800000" flipH="1">
-            <a:off x="10160723" y="9653818"/>
+            <a:off x="10160723" y="9860669"/>
             <a:ext cx="397833" cy="165917"/>
           </a:xfrm>
           <a:prstGeom prst="straightConnector1">
@@ -12172,7 +12172,7 @@
           <p:cNvPr id="539" name="Google Shape;304;p18">
             <a:extLst>
               <a:ext uri="{FF2B5EF4-FFF2-40B4-BE49-F238E27FC236}">
-                <a16:creationId xmlns:a16="http://schemas.microsoft.com/office/drawing/2014/main" id="{80390C8D-EA5D-16B8-F644-62EBD99AA811}"/>
+                <a16:creationId xmlns:a16="http://schemas.microsoft.com/office/drawing/2014/main" id="{CC60A9BB-D748-81AB-B1B7-DE580AE69300}"/>
               </a:ext>
             </a:extLst>
           </p:cNvPr>
@@ -12183,7 +12183,7 @@
         </p:nvCxnSpPr>
         <p:spPr>
           <a:xfrm rot="10800000" flipH="1">
-            <a:off x="10549411" y="9351877"/>
+            <a:off x="10549411" y="9558728"/>
             <a:ext cx="63250" cy="304792"/>
           </a:xfrm>
           <a:prstGeom prst="straightConnector1">
@@ -12206,7 +12206,7 @@
           <p:cNvPr id="540" name="Google Shape;305;p18">
             <a:extLst>
               <a:ext uri="{FF2B5EF4-FFF2-40B4-BE49-F238E27FC236}">
-                <a16:creationId xmlns:a16="http://schemas.microsoft.com/office/drawing/2014/main" id="{1AF4AD71-8DAE-1513-5282-ECD7D4D40AA1}"/>
+                <a16:creationId xmlns:a16="http://schemas.microsoft.com/office/drawing/2014/main" id="{028B352A-3143-A951-EC73-C7A66A7CE32D}"/>
               </a:ext>
             </a:extLst>
           </p:cNvPr>
@@ -12217,7 +12217,7 @@
         </p:nvCxnSpPr>
         <p:spPr>
           <a:xfrm rot="10800000">
-            <a:off x="10615834" y="9370614"/>
+            <a:off x="10615834" y="9577465"/>
             <a:ext cx="191125" cy="289208"/>
           </a:xfrm>
           <a:prstGeom prst="straightConnector1">
@@ -12240,7 +12240,7 @@
           <p:cNvPr id="541" name="Google Shape;306;p18">
             <a:extLst>
               <a:ext uri="{FF2B5EF4-FFF2-40B4-BE49-F238E27FC236}">
-                <a16:creationId xmlns:a16="http://schemas.microsoft.com/office/drawing/2014/main" id="{24FD1FDA-5098-C031-7DA8-82EA54E4371B}"/>
+                <a16:creationId xmlns:a16="http://schemas.microsoft.com/office/drawing/2014/main" id="{7CC38364-2388-E6AC-BCB2-58F307B8F892}"/>
               </a:ext>
             </a:extLst>
           </p:cNvPr>
@@ -12251,7 +12251,7 @@
         </p:nvCxnSpPr>
         <p:spPr>
           <a:xfrm flipH="1">
-            <a:off x="11002049" y="9680994"/>
+            <a:off x="11002049" y="9887845"/>
             <a:ext cx="220458" cy="93958"/>
           </a:xfrm>
           <a:prstGeom prst="straightConnector1">
@@ -12274,7 +12274,7 @@
           <p:cNvPr id="542" name="Google Shape;307;p18">
             <a:extLst>
               <a:ext uri="{FF2B5EF4-FFF2-40B4-BE49-F238E27FC236}">
-                <a16:creationId xmlns:a16="http://schemas.microsoft.com/office/drawing/2014/main" id="{9E653E8C-54F3-2AE0-C249-E1FB445C9E31}"/>
+                <a16:creationId xmlns:a16="http://schemas.microsoft.com/office/drawing/2014/main" id="{2DB5CE86-34CA-C2FD-B442-0E0BEBF7DB4D}"/>
               </a:ext>
             </a:extLst>
           </p:cNvPr>
@@ -12283,7 +12283,7 @@
         </p:nvSpPr>
         <p:spPr>
           <a:xfrm>
-            <a:off x="10105385" y="9584102"/>
+            <a:off x="10105385" y="9790953"/>
             <a:ext cx="69667" cy="69667"/>
           </a:xfrm>
           <a:prstGeom prst="ellipse">
@@ -12318,7 +12318,7 @@
           <p:cNvPr id="543" name="Google Shape;308;p18">
             <a:extLst>
               <a:ext uri="{FF2B5EF4-FFF2-40B4-BE49-F238E27FC236}">
-                <a16:creationId xmlns:a16="http://schemas.microsoft.com/office/drawing/2014/main" id="{4FB319CD-54C8-C15E-01EE-47FD4B42C33C}"/>
+                <a16:creationId xmlns:a16="http://schemas.microsoft.com/office/drawing/2014/main" id="{73C3D9AA-267C-DA5E-70B3-80B2D7A06446}"/>
               </a:ext>
             </a:extLst>
           </p:cNvPr>
@@ -12327,7 +12327,7 @@
         </p:nvSpPr>
         <p:spPr>
           <a:xfrm>
-            <a:off x="10211069" y="9684974"/>
+            <a:off x="10211069" y="9891825"/>
             <a:ext cx="69667" cy="69667"/>
           </a:xfrm>
           <a:prstGeom prst="ellipse">
@@ -12362,7 +12362,7 @@
           <p:cNvPr id="544" name="Google Shape;309;p18">
             <a:extLst>
               <a:ext uri="{FF2B5EF4-FFF2-40B4-BE49-F238E27FC236}">
-                <a16:creationId xmlns:a16="http://schemas.microsoft.com/office/drawing/2014/main" id="{82B4E74F-BF57-DDC4-4841-F180AEE05156}"/>
+                <a16:creationId xmlns:a16="http://schemas.microsoft.com/office/drawing/2014/main" id="{5ABFDF1E-558A-4CAE-3FB5-85547B499EE3}"/>
               </a:ext>
             </a:extLst>
           </p:cNvPr>
@@ -12371,7 +12371,7 @@
         </p:nvSpPr>
         <p:spPr>
           <a:xfrm>
-            <a:off x="10340510" y="9819724"/>
+            <a:off x="10340510" y="10026575"/>
             <a:ext cx="69667" cy="69667"/>
           </a:xfrm>
           <a:prstGeom prst="ellipse">
@@ -12406,7 +12406,7 @@
           <p:cNvPr id="545" name="Google Shape;310;p18">
             <a:extLst>
               <a:ext uri="{FF2B5EF4-FFF2-40B4-BE49-F238E27FC236}">
-                <a16:creationId xmlns:a16="http://schemas.microsoft.com/office/drawing/2014/main" id="{DFB158CB-B7F6-99D9-26A6-D2B19F0333B0}"/>
+                <a16:creationId xmlns:a16="http://schemas.microsoft.com/office/drawing/2014/main" id="{B38447AA-863F-34B3-97A8-3FA0CF52729C}"/>
               </a:ext>
             </a:extLst>
           </p:cNvPr>
@@ -12415,7 +12415,7 @@
         </p:nvSpPr>
         <p:spPr>
           <a:xfrm>
-            <a:off x="10561656" y="9706783"/>
+            <a:off x="10561656" y="9913634"/>
             <a:ext cx="69667" cy="69667"/>
           </a:xfrm>
           <a:prstGeom prst="ellipse">
@@ -12450,7 +12450,7 @@
           <p:cNvPr id="546" name="Google Shape;311;p18">
             <a:extLst>
               <a:ext uri="{FF2B5EF4-FFF2-40B4-BE49-F238E27FC236}">
-                <a16:creationId xmlns:a16="http://schemas.microsoft.com/office/drawing/2014/main" id="{8A1AE323-649C-7F5C-4D2C-2BD73F864881}"/>
+                <a16:creationId xmlns:a16="http://schemas.microsoft.com/office/drawing/2014/main" id="{D55B514B-3FB4-DE07-A57D-9394473155EB}"/>
               </a:ext>
             </a:extLst>
           </p:cNvPr>
@@ -12459,7 +12459,7 @@
         </p:nvSpPr>
         <p:spPr>
           <a:xfrm>
-            <a:off x="10760000" y="9518446"/>
+            <a:off x="10760000" y="9725297"/>
             <a:ext cx="69667" cy="69667"/>
           </a:xfrm>
           <a:prstGeom prst="ellipse">
@@ -12494,7 +12494,7 @@
           <p:cNvPr id="547" name="Google Shape;312;p18">
             <a:extLst>
               <a:ext uri="{FF2B5EF4-FFF2-40B4-BE49-F238E27FC236}">
-                <a16:creationId xmlns:a16="http://schemas.microsoft.com/office/drawing/2014/main" id="{AC23E29A-4B1A-5E4B-A485-40503B6E0AC9}"/>
+                <a16:creationId xmlns:a16="http://schemas.microsoft.com/office/drawing/2014/main" id="{1086335A-47AF-381F-4C92-47A324DC8E89}"/>
               </a:ext>
             </a:extLst>
           </p:cNvPr>
@@ -12503,7 +12503,7 @@
         </p:nvSpPr>
         <p:spPr>
           <a:xfrm>
-            <a:off x="11150691" y="9503550"/>
+            <a:off x="11150691" y="9710401"/>
             <a:ext cx="69667" cy="69667"/>
           </a:xfrm>
           <a:prstGeom prst="ellipse">
@@ -12538,7 +12538,7 @@
           <p:cNvPr id="548" name="Google Shape;313;p18">
             <a:extLst>
               <a:ext uri="{FF2B5EF4-FFF2-40B4-BE49-F238E27FC236}">
-                <a16:creationId xmlns:a16="http://schemas.microsoft.com/office/drawing/2014/main" id="{154FD6DA-A8AE-A227-9028-593E8402FFA4}"/>
+                <a16:creationId xmlns:a16="http://schemas.microsoft.com/office/drawing/2014/main" id="{BC368A7F-3FDE-CB5F-BF81-F36A3AF93E0E}"/>
               </a:ext>
             </a:extLst>
           </p:cNvPr>
@@ -12547,7 +12547,7 @@
         </p:nvSpPr>
         <p:spPr>
           <a:xfrm>
-            <a:off x="10134145" y="9776449"/>
+            <a:off x="10134145" y="9983300"/>
             <a:ext cx="69667" cy="69667"/>
           </a:xfrm>
           <a:prstGeom prst="ellipse">
@@ -12582,7 +12582,7 @@
           <p:cNvPr id="549" name="Google Shape;314;p18">
             <a:extLst>
               <a:ext uri="{FF2B5EF4-FFF2-40B4-BE49-F238E27FC236}">
-                <a16:creationId xmlns:a16="http://schemas.microsoft.com/office/drawing/2014/main" id="{F2AF32A2-BE04-79C3-3549-0BF0EA850D02}"/>
+                <a16:creationId xmlns:a16="http://schemas.microsoft.com/office/drawing/2014/main" id="{37289B09-2766-B536-8838-45493E71D2EE}"/>
               </a:ext>
             </a:extLst>
           </p:cNvPr>
@@ -12591,7 +12591,7 @@
         </p:nvSpPr>
         <p:spPr>
           <a:xfrm>
-            <a:off x="10508891" y="9622297"/>
+            <a:off x="10508891" y="9829148"/>
             <a:ext cx="69667" cy="69667"/>
           </a:xfrm>
           <a:prstGeom prst="ellipse">
@@ -12626,7 +12626,7 @@
           <p:cNvPr id="550" name="Google Shape;315;p18">
             <a:extLst>
               <a:ext uri="{FF2B5EF4-FFF2-40B4-BE49-F238E27FC236}">
-                <a16:creationId xmlns:a16="http://schemas.microsoft.com/office/drawing/2014/main" id="{EF15E0CF-6EBA-6C61-C570-31A110857773}"/>
+                <a16:creationId xmlns:a16="http://schemas.microsoft.com/office/drawing/2014/main" id="{35C0E135-D259-4D1A-33E3-A5C14AE63595}"/>
               </a:ext>
             </a:extLst>
           </p:cNvPr>
@@ -12635,7 +12635,7 @@
         </p:nvSpPr>
         <p:spPr>
           <a:xfrm>
-            <a:off x="10589672" y="9340727"/>
+            <a:off x="10589672" y="9547578"/>
             <a:ext cx="69667" cy="69667"/>
           </a:xfrm>
           <a:prstGeom prst="ellipse">
@@ -12670,7 +12670,7 @@
           <p:cNvPr id="551" name="Google Shape;316;p18">
             <a:extLst>
               <a:ext uri="{FF2B5EF4-FFF2-40B4-BE49-F238E27FC236}">
-                <a16:creationId xmlns:a16="http://schemas.microsoft.com/office/drawing/2014/main" id="{0489AA5E-3BB1-C79B-8E77-D83DDC3015EE}"/>
+                <a16:creationId xmlns:a16="http://schemas.microsoft.com/office/drawing/2014/main" id="{309C9BDD-D607-2986-4E76-3F0C13A58541}"/>
               </a:ext>
             </a:extLst>
           </p:cNvPr>
@@ -12679,7 +12679,7 @@
         </p:nvSpPr>
         <p:spPr>
           <a:xfrm>
-            <a:off x="10775756" y="9622297"/>
+            <a:off x="10775756" y="9829148"/>
             <a:ext cx="69667" cy="69667"/>
           </a:xfrm>
           <a:prstGeom prst="ellipse">
@@ -12714,7 +12714,7 @@
           <p:cNvPr id="552" name="Google Shape;317;p18">
             <a:extLst>
               <a:ext uri="{FF2B5EF4-FFF2-40B4-BE49-F238E27FC236}">
-                <a16:creationId xmlns:a16="http://schemas.microsoft.com/office/drawing/2014/main" id="{4A46BADA-87BC-5E23-B0CC-08BD2E6E1A4F}"/>
+                <a16:creationId xmlns:a16="http://schemas.microsoft.com/office/drawing/2014/main" id="{CA674386-CAD9-98C1-17B7-077DF7A43110}"/>
               </a:ext>
             </a:extLst>
           </p:cNvPr>
@@ -12723,7 +12723,7 @@
         </p:nvSpPr>
         <p:spPr>
           <a:xfrm>
-            <a:off x="10959356" y="9741769"/>
+            <a:off x="10959356" y="9948620"/>
             <a:ext cx="69667" cy="69667"/>
           </a:xfrm>
           <a:prstGeom prst="ellipse">
@@ -12758,7 +12758,7 @@
           <p:cNvPr id="553" name="Google Shape;318;p18">
             <a:extLst>
               <a:ext uri="{FF2B5EF4-FFF2-40B4-BE49-F238E27FC236}">
-                <a16:creationId xmlns:a16="http://schemas.microsoft.com/office/drawing/2014/main" id="{FFC4B0B1-A0D9-F08C-1722-7863D5A5BEA0}"/>
+                <a16:creationId xmlns:a16="http://schemas.microsoft.com/office/drawing/2014/main" id="{B0DE4801-FE74-EFE7-8671-CB1BD6117899}"/>
               </a:ext>
             </a:extLst>
           </p:cNvPr>
@@ -12767,7 +12767,7 @@
         </p:nvSpPr>
         <p:spPr>
           <a:xfrm>
-            <a:off x="11186499" y="9656672"/>
+            <a:off x="11186499" y="9863523"/>
             <a:ext cx="69667" cy="69667"/>
           </a:xfrm>
           <a:prstGeom prst="ellipse">
@@ -12802,7 +12802,7 @@
           <p:cNvPr id="554" name="Google Shape;320;p18">
             <a:extLst>
               <a:ext uri="{FF2B5EF4-FFF2-40B4-BE49-F238E27FC236}">
-                <a16:creationId xmlns:a16="http://schemas.microsoft.com/office/drawing/2014/main" id="{69BF32FD-F1CF-AE36-096F-7CE42097919F}"/>
+                <a16:creationId xmlns:a16="http://schemas.microsoft.com/office/drawing/2014/main" id="{59DB266A-DD9F-EA7E-54B2-2B43FF9733A4}"/>
               </a:ext>
             </a:extLst>
           </p:cNvPr>
@@ -12811,7 +12811,7 @@
         </p:nvSpPr>
         <p:spPr>
           <a:xfrm>
-            <a:off x="11654458" y="9548645"/>
+            <a:off x="11654458" y="9755496"/>
             <a:ext cx="109507" cy="116681"/>
           </a:xfrm>
           <a:prstGeom prst="rect">
@@ -12850,7 +12850,7 @@
           <p:cNvPr id="555" name="Google Shape;321;p18">
             <a:extLst>
               <a:ext uri="{FF2B5EF4-FFF2-40B4-BE49-F238E27FC236}">
-                <a16:creationId xmlns:a16="http://schemas.microsoft.com/office/drawing/2014/main" id="{2B74ED1A-6349-67F5-6DB4-C79042C2B02D}"/>
+                <a16:creationId xmlns:a16="http://schemas.microsoft.com/office/drawing/2014/main" id="{D428E07F-5067-19E9-C303-FFEB907F6319}"/>
               </a:ext>
             </a:extLst>
           </p:cNvPr>
@@ -12859,7 +12859,7 @@
         </p:nvSpPr>
         <p:spPr>
           <a:xfrm>
-            <a:off x="11701136" y="9384268"/>
+            <a:off x="11701136" y="9591119"/>
             <a:ext cx="1924501" cy="399667"/>
           </a:xfrm>
           <a:prstGeom prst="rect">
@@ -12905,7 +12905,7 @@
           <p:cNvPr id="556" name="Google Shape;322;p18">
             <a:extLst>
               <a:ext uri="{FF2B5EF4-FFF2-40B4-BE49-F238E27FC236}">
-                <a16:creationId xmlns:a16="http://schemas.microsoft.com/office/drawing/2014/main" id="{F6883A22-CFE0-1C5B-D7D5-E6A2EE794AA0}"/>
+                <a16:creationId xmlns:a16="http://schemas.microsoft.com/office/drawing/2014/main" id="{E4774A0A-0A4E-9937-D1EC-263369B7B816}"/>
               </a:ext>
             </a:extLst>
           </p:cNvPr>
@@ -12914,7 +12914,7 @@
         </p:nvSpPr>
         <p:spPr>
           <a:xfrm>
-            <a:off x="11701136" y="9059354"/>
+            <a:off x="11701136" y="9266205"/>
             <a:ext cx="2332976" cy="399667"/>
           </a:xfrm>
           <a:prstGeom prst="rect">
@@ -12972,7 +12972,7 @@
           <p:cNvPr id="557" name="Google Shape;292;p18">
             <a:extLst>
               <a:ext uri="{FF2B5EF4-FFF2-40B4-BE49-F238E27FC236}">
-                <a16:creationId xmlns:a16="http://schemas.microsoft.com/office/drawing/2014/main" id="{51ADE1D9-140A-E990-30D7-FB0294D63D54}"/>
+                <a16:creationId xmlns:a16="http://schemas.microsoft.com/office/drawing/2014/main" id="{112830B0-8576-E526-E10F-B159453CA614}"/>
               </a:ext>
             </a:extLst>
           </p:cNvPr>
@@ -12981,7 +12981,7 @@
         </p:nvSpPr>
         <p:spPr>
           <a:xfrm>
-            <a:off x="9735851" y="6977723"/>
+            <a:off x="9735851" y="7184574"/>
             <a:ext cx="246674" cy="249601"/>
           </a:xfrm>
           <a:prstGeom prst="ellipse">
@@ -13016,7 +13016,7 @@
           <p:cNvPr id="558" name="Google Shape;293;p18">
             <a:extLst>
               <a:ext uri="{FF2B5EF4-FFF2-40B4-BE49-F238E27FC236}">
-                <a16:creationId xmlns:a16="http://schemas.microsoft.com/office/drawing/2014/main" id="{39209D3C-E73F-A150-709C-CDA9362C0D6E}"/>
+                <a16:creationId xmlns:a16="http://schemas.microsoft.com/office/drawing/2014/main" id="{E9AAD38E-7045-620B-CAC7-2B5E3D30A062}"/>
               </a:ext>
             </a:extLst>
           </p:cNvPr>
@@ -13025,7 +13025,7 @@
         </p:nvSpPr>
         <p:spPr>
           <a:xfrm>
-            <a:off x="9628606" y="6945086"/>
+            <a:off x="9628606" y="7151937"/>
             <a:ext cx="480515" cy="157250"/>
           </a:xfrm>
           <a:prstGeom prst="rect">
@@ -13065,7 +13065,7 @@
           <p:cNvPr id="559" name="Google Shape;292;p18">
             <a:extLst>
               <a:ext uri="{FF2B5EF4-FFF2-40B4-BE49-F238E27FC236}">
-                <a16:creationId xmlns:a16="http://schemas.microsoft.com/office/drawing/2014/main" id="{8FBEBE27-18D0-C0FB-C4E2-9B993374A8D2}"/>
+                <a16:creationId xmlns:a16="http://schemas.microsoft.com/office/drawing/2014/main" id="{34B24FEB-B647-2FFC-9531-147CCB4141D8}"/>
               </a:ext>
             </a:extLst>
           </p:cNvPr>
@@ -13074,7 +13074,7 @@
         </p:nvSpPr>
         <p:spPr>
           <a:xfrm>
-            <a:off x="12432773" y="6820794"/>
+            <a:off x="12432773" y="7027645"/>
             <a:ext cx="246674" cy="249601"/>
           </a:xfrm>
           <a:prstGeom prst="ellipse">
@@ -13109,7 +13109,7 @@
           <p:cNvPr id="560" name="Google Shape;293;p18">
             <a:extLst>
               <a:ext uri="{FF2B5EF4-FFF2-40B4-BE49-F238E27FC236}">
-                <a16:creationId xmlns:a16="http://schemas.microsoft.com/office/drawing/2014/main" id="{982C3487-74C4-539D-F43A-255E73F4844E}"/>
+                <a16:creationId xmlns:a16="http://schemas.microsoft.com/office/drawing/2014/main" id="{AABFA1BB-4420-D931-12FC-CA2453DAC574}"/>
               </a:ext>
             </a:extLst>
           </p:cNvPr>
@@ -13118,7 +13118,7 @@
         </p:nvSpPr>
         <p:spPr>
           <a:xfrm>
-            <a:off x="12382678" y="6788157"/>
+            <a:off x="12382678" y="6995008"/>
             <a:ext cx="480515" cy="157250"/>
           </a:xfrm>
           <a:prstGeom prst="rect">
@@ -13158,7 +13158,7 @@
           <p:cNvPr id="561" name="Google Shape;292;p18">
             <a:extLst>
               <a:ext uri="{FF2B5EF4-FFF2-40B4-BE49-F238E27FC236}">
-                <a16:creationId xmlns:a16="http://schemas.microsoft.com/office/drawing/2014/main" id="{58F68459-6F1C-A7F1-9987-F6DDE9F09761}"/>
+                <a16:creationId xmlns:a16="http://schemas.microsoft.com/office/drawing/2014/main" id="{710DAC85-71C1-3BB1-D396-A988A752FE18}"/>
               </a:ext>
             </a:extLst>
           </p:cNvPr>
@@ -13167,7 +13167,7 @@
         </p:nvSpPr>
         <p:spPr>
           <a:xfrm>
-            <a:off x="9612245" y="6688526"/>
+            <a:off x="9612245" y="6895377"/>
             <a:ext cx="246674" cy="249601"/>
           </a:xfrm>
           <a:prstGeom prst="ellipse">
@@ -13202,7 +13202,7 @@
           <p:cNvPr id="562" name="Google Shape;293;p18">
             <a:extLst>
               <a:ext uri="{FF2B5EF4-FFF2-40B4-BE49-F238E27FC236}">
-                <a16:creationId xmlns:a16="http://schemas.microsoft.com/office/drawing/2014/main" id="{6826596B-7494-1489-C456-6530F291B5D8}"/>
+                <a16:creationId xmlns:a16="http://schemas.microsoft.com/office/drawing/2014/main" id="{6596327A-DA23-81C3-3567-6BD7F145B928}"/>
               </a:ext>
             </a:extLst>
           </p:cNvPr>
@@ -13211,7 +13211,7 @@
         </p:nvSpPr>
         <p:spPr>
           <a:xfrm>
-            <a:off x="9568500" y="6655889"/>
+            <a:off x="9568500" y="6862740"/>
             <a:ext cx="480515" cy="157250"/>
           </a:xfrm>
           <a:prstGeom prst="rect">
@@ -13251,7 +13251,7 @@
           <p:cNvPr id="563" name="Google Shape;292;p18">
             <a:extLst>
               <a:ext uri="{FF2B5EF4-FFF2-40B4-BE49-F238E27FC236}">
-                <a16:creationId xmlns:a16="http://schemas.microsoft.com/office/drawing/2014/main" id="{3B2962FC-A390-50B1-4CD6-33B2B1F1C1D2}"/>
+                <a16:creationId xmlns:a16="http://schemas.microsoft.com/office/drawing/2014/main" id="{1EC68D32-79D9-80EC-9254-C4128AD89196}"/>
               </a:ext>
             </a:extLst>
           </p:cNvPr>
@@ -13260,7 +13260,7 @@
         </p:nvSpPr>
         <p:spPr>
           <a:xfrm>
-            <a:off x="9864308" y="6696773"/>
+            <a:off x="9864308" y="6903624"/>
             <a:ext cx="246674" cy="249601"/>
           </a:xfrm>
           <a:prstGeom prst="ellipse">
@@ -13295,7 +13295,7 @@
           <p:cNvPr id="564" name="Google Shape;293;p18">
             <a:extLst>
               <a:ext uri="{FF2B5EF4-FFF2-40B4-BE49-F238E27FC236}">
-                <a16:creationId xmlns:a16="http://schemas.microsoft.com/office/drawing/2014/main" id="{D8A16CEE-D6CD-ED24-E26F-3697AAE4FFE6}"/>
+                <a16:creationId xmlns:a16="http://schemas.microsoft.com/office/drawing/2014/main" id="{E9F0AD8B-3705-69FE-85D5-DC58D03859DD}"/>
               </a:ext>
             </a:extLst>
           </p:cNvPr>
@@ -13304,7 +13304,7 @@
         </p:nvSpPr>
         <p:spPr>
           <a:xfrm>
-            <a:off x="9757063" y="6664136"/>
+            <a:off x="9757063" y="6870987"/>
             <a:ext cx="480515" cy="157250"/>
           </a:xfrm>
           <a:prstGeom prst="rect">
@@ -13344,7 +13344,7 @@
           <p:cNvPr id="565" name="Google Shape;248;p18">
             <a:extLst>
               <a:ext uri="{FF2B5EF4-FFF2-40B4-BE49-F238E27FC236}">
-                <a16:creationId xmlns:a16="http://schemas.microsoft.com/office/drawing/2014/main" id="{1673BCAB-15A9-188D-91E2-7CEA1B9D3CD2}"/>
+                <a16:creationId xmlns:a16="http://schemas.microsoft.com/office/drawing/2014/main" id="{5A27AE24-5BE0-D04A-E4AD-F455D82969E7}"/>
               </a:ext>
             </a:extLst>
           </p:cNvPr>
@@ -13361,7 +13361,7 @@
         </p:blipFill>
         <p:spPr>
           <a:xfrm>
-            <a:off x="10013212" y="7303190"/>
+            <a:off x="10013212" y="7510041"/>
             <a:ext cx="809211" cy="470250"/>
           </a:xfrm>
           <a:prstGeom prst="rect">
@@ -13378,7 +13378,7 @@
           <p:cNvPr id="566" name="Google Shape;249;p18">
             <a:extLst>
               <a:ext uri="{FF2B5EF4-FFF2-40B4-BE49-F238E27FC236}">
-                <a16:creationId xmlns:a16="http://schemas.microsoft.com/office/drawing/2014/main" id="{A7878617-C69F-91D9-FB91-D568834DAC57}"/>
+                <a16:creationId xmlns:a16="http://schemas.microsoft.com/office/drawing/2014/main" id="{427C6920-E116-A33F-DD17-4EB96C9B4814}"/>
               </a:ext>
             </a:extLst>
           </p:cNvPr>
@@ -13389,7 +13389,7 @@
         </p:nvCxnSpPr>
         <p:spPr>
           <a:xfrm>
-            <a:off x="10149297" y="7846944"/>
+            <a:off x="10149297" y="8053795"/>
             <a:ext cx="547919" cy="2275"/>
           </a:xfrm>
           <a:prstGeom prst="straightConnector1">
@@ -13412,7 +13412,7 @@
           <p:cNvPr id="567" name="Google Shape;253;p18">
             <a:extLst>
               <a:ext uri="{FF2B5EF4-FFF2-40B4-BE49-F238E27FC236}">
-                <a16:creationId xmlns:a16="http://schemas.microsoft.com/office/drawing/2014/main" id="{15AF44AD-813D-01A7-AC56-3E1C2B21273F}"/>
+                <a16:creationId xmlns:a16="http://schemas.microsoft.com/office/drawing/2014/main" id="{31A9F53D-C532-40B0-CDE7-7877760D938D}"/>
               </a:ext>
             </a:extLst>
           </p:cNvPr>
@@ -13421,7 +13421,7 @@
         </p:nvSpPr>
         <p:spPr>
           <a:xfrm>
-            <a:off x="10609063" y="7302882"/>
+            <a:off x="10609063" y="7509733"/>
             <a:ext cx="1416856" cy="466748"/>
           </a:xfrm>
           <a:prstGeom prst="rect">
@@ -13467,7 +13467,7 @@
           <p:cNvPr id="568" name="Google Shape;254;p18">
             <a:extLst>
               <a:ext uri="{FF2B5EF4-FFF2-40B4-BE49-F238E27FC236}">
-                <a16:creationId xmlns:a16="http://schemas.microsoft.com/office/drawing/2014/main" id="{412BC80E-A462-0994-85B5-FB4E208E74F3}"/>
+                <a16:creationId xmlns:a16="http://schemas.microsoft.com/office/drawing/2014/main" id="{A4E4E6B8-28F1-B75E-B539-4186290D10E0}"/>
               </a:ext>
             </a:extLst>
           </p:cNvPr>
@@ -13476,7 +13476,7 @@
         </p:nvSpPr>
         <p:spPr>
           <a:xfrm>
-            <a:off x="11832014" y="7301517"/>
+            <a:off x="11832014" y="7508368"/>
             <a:ext cx="678035" cy="466748"/>
           </a:xfrm>
           <a:prstGeom prst="rect">
@@ -13522,7 +13522,7 @@
           <p:cNvPr id="569" name="Google Shape;255;p18">
             <a:extLst>
               <a:ext uri="{FF2B5EF4-FFF2-40B4-BE49-F238E27FC236}">
-                <a16:creationId xmlns:a16="http://schemas.microsoft.com/office/drawing/2014/main" id="{29B6A096-31C8-674A-B266-8EC3D82DD4D5}"/>
+                <a16:creationId xmlns:a16="http://schemas.microsoft.com/office/drawing/2014/main" id="{FF0F49DA-E83B-F2DC-4B3D-C11299D3F71A}"/>
               </a:ext>
             </a:extLst>
           </p:cNvPr>
@@ -13531,7 +13531,7 @@
         </p:nvSpPr>
         <p:spPr>
           <a:xfrm>
-            <a:off x="12523990" y="7301203"/>
+            <a:off x="12523990" y="7508054"/>
             <a:ext cx="537849" cy="466748"/>
           </a:xfrm>
           <a:prstGeom prst="rect">
@@ -13577,7 +13577,7 @@
           <p:cNvPr id="570" name="Google Shape;292;p18">
             <a:extLst>
               <a:ext uri="{FF2B5EF4-FFF2-40B4-BE49-F238E27FC236}">
-                <a16:creationId xmlns:a16="http://schemas.microsoft.com/office/drawing/2014/main" id="{F3CC8320-F1B0-0516-0B43-23680A27DC6F}"/>
+                <a16:creationId xmlns:a16="http://schemas.microsoft.com/office/drawing/2014/main" id="{DD7CA647-302A-9FEE-32FE-14846E3D6D26}"/>
               </a:ext>
             </a:extLst>
           </p:cNvPr>
@@ -13586,7 +13586,7 @@
         </p:nvSpPr>
         <p:spPr>
           <a:xfrm>
-            <a:off x="12292076" y="7399129"/>
+            <a:off x="12292076" y="7605980"/>
             <a:ext cx="246674" cy="249601"/>
           </a:xfrm>
           <a:prstGeom prst="ellipse">
@@ -13621,7 +13621,7 @@
           <p:cNvPr id="571" name="Google Shape;293;p18">
             <a:extLst>
               <a:ext uri="{FF2B5EF4-FFF2-40B4-BE49-F238E27FC236}">
-                <a16:creationId xmlns:a16="http://schemas.microsoft.com/office/drawing/2014/main" id="{733BF473-1A9D-744B-C935-D404DE1463BF}"/>
+                <a16:creationId xmlns:a16="http://schemas.microsoft.com/office/drawing/2014/main" id="{A1C991A3-C666-1AD4-A61F-C26614542400}"/>
               </a:ext>
             </a:extLst>
           </p:cNvPr>
@@ -13630,7 +13630,7 @@
         </p:nvSpPr>
         <p:spPr>
           <a:xfrm>
-            <a:off x="12153873" y="7366492"/>
+            <a:off x="12153873" y="7573343"/>
             <a:ext cx="564637" cy="157250"/>
           </a:xfrm>
           <a:prstGeom prst="rect">
@@ -13670,7 +13670,7 @@
           <p:cNvPr id="572" name="Google Shape;292;p18">
             <a:extLst>
               <a:ext uri="{FF2B5EF4-FFF2-40B4-BE49-F238E27FC236}">
-                <a16:creationId xmlns:a16="http://schemas.microsoft.com/office/drawing/2014/main" id="{29698CD6-C7F8-F29A-8AC2-E895121BEA06}"/>
+                <a16:creationId xmlns:a16="http://schemas.microsoft.com/office/drawing/2014/main" id="{9148A471-1C99-2387-7651-C53053FF9876}"/>
               </a:ext>
             </a:extLst>
           </p:cNvPr>
@@ -13679,7 +13679,7 @@
         </p:nvSpPr>
         <p:spPr>
           <a:xfrm>
-            <a:off x="10149975" y="7530323"/>
+            <a:off x="10149975" y="7737174"/>
             <a:ext cx="246674" cy="249601"/>
           </a:xfrm>
           <a:prstGeom prst="ellipse">
@@ -13714,7 +13714,7 @@
           <p:cNvPr id="573" name="Google Shape;293;p18">
             <a:extLst>
               <a:ext uri="{FF2B5EF4-FFF2-40B4-BE49-F238E27FC236}">
-                <a16:creationId xmlns:a16="http://schemas.microsoft.com/office/drawing/2014/main" id="{26216C2C-4995-511F-76A2-C1FD965DAB9D}"/>
+                <a16:creationId xmlns:a16="http://schemas.microsoft.com/office/drawing/2014/main" id="{6ACCEAF1-571E-E88D-F046-ADF6665F3265}"/>
               </a:ext>
             </a:extLst>
           </p:cNvPr>
@@ -13723,7 +13723,7 @@
         </p:nvSpPr>
         <p:spPr>
           <a:xfrm>
-            <a:off x="10042730" y="7497686"/>
+            <a:off x="10042730" y="7704537"/>
             <a:ext cx="480515" cy="157250"/>
           </a:xfrm>
           <a:prstGeom prst="rect">
@@ -13763,7 +13763,7 @@
           <p:cNvPr id="574" name="Google Shape;292;p18">
             <a:extLst>
               <a:ext uri="{FF2B5EF4-FFF2-40B4-BE49-F238E27FC236}">
-                <a16:creationId xmlns:a16="http://schemas.microsoft.com/office/drawing/2014/main" id="{8FA9D1BC-2DAC-B1E0-8F98-0A07F9341364}"/>
+                <a16:creationId xmlns:a16="http://schemas.microsoft.com/office/drawing/2014/main" id="{4AF1D507-74FA-21B8-8F58-BAD083506071}"/>
               </a:ext>
             </a:extLst>
           </p:cNvPr>
@@ -13772,7 +13772,7 @@
         </p:nvSpPr>
         <p:spPr>
           <a:xfrm>
-            <a:off x="12969116" y="7394647"/>
+            <a:off x="12969116" y="7601498"/>
             <a:ext cx="246674" cy="249601"/>
           </a:xfrm>
           <a:prstGeom prst="ellipse">
@@ -13807,7 +13807,7 @@
           <p:cNvPr id="575" name="Google Shape;293;p18">
             <a:extLst>
               <a:ext uri="{FF2B5EF4-FFF2-40B4-BE49-F238E27FC236}">
-                <a16:creationId xmlns:a16="http://schemas.microsoft.com/office/drawing/2014/main" id="{A22D0F5E-6B14-567C-E980-BDFE0E73AAA6}"/>
+                <a16:creationId xmlns:a16="http://schemas.microsoft.com/office/drawing/2014/main" id="{94B76E4B-C43F-0CBA-8FC7-D8A576EC448C}"/>
               </a:ext>
             </a:extLst>
           </p:cNvPr>
@@ -13816,7 +13816,7 @@
         </p:nvSpPr>
         <p:spPr>
           <a:xfrm>
-            <a:off x="12919021" y="7371535"/>
+            <a:off x="12919021" y="7578386"/>
             <a:ext cx="480515" cy="157250"/>
           </a:xfrm>
           <a:prstGeom prst="rect">
@@ -13856,7 +13856,7 @@
           <p:cNvPr id="192" name="Google Shape;292;p18">
             <a:extLst>
               <a:ext uri="{FF2B5EF4-FFF2-40B4-BE49-F238E27FC236}">
-                <a16:creationId xmlns:a16="http://schemas.microsoft.com/office/drawing/2014/main" id="{C4710EF4-F989-76B9-5E49-D3D2657A26F0}"/>
+                <a16:creationId xmlns:a16="http://schemas.microsoft.com/office/drawing/2014/main" id="{45F2E523-394B-6900-CFF3-701919CB6D47}"/>
               </a:ext>
             </a:extLst>
           </p:cNvPr>
@@ -13865,7 +13865,7 @@
         </p:nvSpPr>
         <p:spPr>
           <a:xfrm>
-            <a:off x="10148588" y="7262379"/>
+            <a:off x="10148588" y="7469230"/>
             <a:ext cx="246674" cy="249601"/>
           </a:xfrm>
           <a:prstGeom prst="ellipse">
@@ -13900,7 +13900,7 @@
           <p:cNvPr id="193" name="Google Shape;293;p18">
             <a:extLst>
               <a:ext uri="{FF2B5EF4-FFF2-40B4-BE49-F238E27FC236}">
-                <a16:creationId xmlns:a16="http://schemas.microsoft.com/office/drawing/2014/main" id="{7D2F9CFE-6522-FD79-CFD0-D98012009A46}"/>
+                <a16:creationId xmlns:a16="http://schemas.microsoft.com/office/drawing/2014/main" id="{9F454ACD-285F-9B8A-4615-AF05006F0F5D}"/>
               </a:ext>
             </a:extLst>
           </p:cNvPr>
@@ -13909,7 +13909,7 @@
         </p:nvSpPr>
         <p:spPr>
           <a:xfrm>
-            <a:off x="10012771" y="7227361"/>
+            <a:off x="10012771" y="7434212"/>
             <a:ext cx="574525" cy="157250"/>
           </a:xfrm>
           <a:prstGeom prst="rect">
@@ -13949,7 +13949,7 @@
           <p:cNvPr id="194" name="Google Shape;292;p18">
             <a:extLst>
               <a:ext uri="{FF2B5EF4-FFF2-40B4-BE49-F238E27FC236}">
-                <a16:creationId xmlns:a16="http://schemas.microsoft.com/office/drawing/2014/main" id="{1ECBE82D-B179-25C8-3D71-AB644D90B77B}"/>
+                <a16:creationId xmlns:a16="http://schemas.microsoft.com/office/drawing/2014/main" id="{AED6E957-FB0E-1B1D-3C51-6627BD0EBD69}"/>
               </a:ext>
             </a:extLst>
           </p:cNvPr>
@@ -13958,7 +13958,7 @@
         </p:nvSpPr>
         <p:spPr>
           <a:xfrm>
-            <a:off x="10400651" y="7270626"/>
+            <a:off x="10400651" y="7477477"/>
             <a:ext cx="246674" cy="249601"/>
           </a:xfrm>
           <a:prstGeom prst="ellipse">
@@ -13993,7 +13993,7 @@
           <p:cNvPr id="195" name="Google Shape;293;p18">
             <a:extLst>
               <a:ext uri="{FF2B5EF4-FFF2-40B4-BE49-F238E27FC236}">
-                <a16:creationId xmlns:a16="http://schemas.microsoft.com/office/drawing/2014/main" id="{1EBD7996-FE64-014C-935F-6A0E6131DB31}"/>
+                <a16:creationId xmlns:a16="http://schemas.microsoft.com/office/drawing/2014/main" id="{FB744BED-9278-1E82-7441-BF4C9B64FA3B}"/>
               </a:ext>
             </a:extLst>
           </p:cNvPr>
@@ -14002,7 +14002,7 @@
         </p:nvSpPr>
         <p:spPr>
           <a:xfrm>
-            <a:off x="10344206" y="7237989"/>
+            <a:off x="10344206" y="7444840"/>
             <a:ext cx="480515" cy="157250"/>
           </a:xfrm>
           <a:prstGeom prst="rect">
@@ -14042,7 +14042,7 @@
           <p:cNvPr id="196" name="Google Shape;292;p18">
             <a:extLst>
               <a:ext uri="{FF2B5EF4-FFF2-40B4-BE49-F238E27FC236}">
-                <a16:creationId xmlns:a16="http://schemas.microsoft.com/office/drawing/2014/main" id="{C0BC3F63-3243-3265-8576-BC5F114D02C4}"/>
+                <a16:creationId xmlns:a16="http://schemas.microsoft.com/office/drawing/2014/main" id="{ACC42535-6F44-5DD2-FE73-0BB0BF0E2D6C}"/>
               </a:ext>
             </a:extLst>
           </p:cNvPr>
@@ -14051,7 +14051,7 @@
         </p:nvSpPr>
         <p:spPr>
           <a:xfrm>
-            <a:off x="10412947" y="7538934"/>
+            <a:off x="10412947" y="7745785"/>
             <a:ext cx="246674" cy="249601"/>
           </a:xfrm>
           <a:prstGeom prst="ellipse">
@@ -14086,7 +14086,7 @@
           <p:cNvPr id="197" name="Google Shape;293;p18">
             <a:extLst>
               <a:ext uri="{FF2B5EF4-FFF2-40B4-BE49-F238E27FC236}">
-                <a16:creationId xmlns:a16="http://schemas.microsoft.com/office/drawing/2014/main" id="{3D514178-4B0E-119D-94DD-4919F2023407}"/>
+                <a16:creationId xmlns:a16="http://schemas.microsoft.com/office/drawing/2014/main" id="{1683B79A-F842-A162-6674-A0C6DAED3C6F}"/>
               </a:ext>
             </a:extLst>
           </p:cNvPr>
@@ -14095,7 +14095,7 @@
         </p:nvSpPr>
         <p:spPr>
           <a:xfrm>
-            <a:off x="10274746" y="7503915"/>
+            <a:off x="10274746" y="7710766"/>
             <a:ext cx="546544" cy="157250"/>
           </a:xfrm>
           <a:prstGeom prst="rect">
@@ -14135,7 +14135,7 @@
           <p:cNvPr id="198" name="Google Shape;389;p18">
             <a:extLst>
               <a:ext uri="{FF2B5EF4-FFF2-40B4-BE49-F238E27FC236}">
-                <a16:creationId xmlns:a16="http://schemas.microsoft.com/office/drawing/2014/main" id="{9F286E90-B5AC-6C1B-A918-DFD0858E2B20}"/>
+                <a16:creationId xmlns:a16="http://schemas.microsoft.com/office/drawing/2014/main" id="{50ED3D79-0703-235D-A387-19C845EF9512}"/>
               </a:ext>
             </a:extLst>
           </p:cNvPr>
@@ -14146,7 +14146,7 @@
         </p:nvCxnSpPr>
         <p:spPr>
           <a:xfrm>
-            <a:off x="10394759" y="7973295"/>
+            <a:off x="10394759" y="8180146"/>
             <a:ext cx="0" cy="325081"/>
           </a:xfrm>
           <a:prstGeom prst="straightConnector1">
@@ -14169,7 +14169,7 @@
           <p:cNvPr id="199" name="Google Shape;248;p18">
             <a:extLst>
               <a:ext uri="{FF2B5EF4-FFF2-40B4-BE49-F238E27FC236}">
-                <a16:creationId xmlns:a16="http://schemas.microsoft.com/office/drawing/2014/main" id="{F70A6B12-981B-6BF8-58CD-96A455AAE051}"/>
+                <a16:creationId xmlns:a16="http://schemas.microsoft.com/office/drawing/2014/main" id="{EE7D240E-9386-7DEA-0A01-42B566A235CE}"/>
               </a:ext>
             </a:extLst>
           </p:cNvPr>
@@ -14186,7 +14186,7 @@
         </p:blipFill>
         <p:spPr>
           <a:xfrm>
-            <a:off x="10554840" y="8273346"/>
+            <a:off x="10554840" y="8480197"/>
             <a:ext cx="809211" cy="470250"/>
           </a:xfrm>
           <a:prstGeom prst="rect">
@@ -14203,7 +14203,7 @@
           <p:cNvPr id="200" name="Google Shape;249;p18">
             <a:extLst>
               <a:ext uri="{FF2B5EF4-FFF2-40B4-BE49-F238E27FC236}">
-                <a16:creationId xmlns:a16="http://schemas.microsoft.com/office/drawing/2014/main" id="{CE39114D-3A17-58C2-10B5-AF6EF529C9A0}"/>
+                <a16:creationId xmlns:a16="http://schemas.microsoft.com/office/drawing/2014/main" id="{87FF321C-032D-2156-71CD-E5DC54635436}"/>
               </a:ext>
             </a:extLst>
           </p:cNvPr>
@@ -14214,7 +14214,7 @@
         </p:nvCxnSpPr>
         <p:spPr>
           <a:xfrm>
-            <a:off x="10690925" y="8817100"/>
+            <a:off x="10690925" y="9023951"/>
             <a:ext cx="547919" cy="2275"/>
           </a:xfrm>
           <a:prstGeom prst="straightConnector1">
@@ -14237,7 +14237,7 @@
           <p:cNvPr id="201" name="Google Shape;253;p18">
             <a:extLst>
               <a:ext uri="{FF2B5EF4-FFF2-40B4-BE49-F238E27FC236}">
-                <a16:creationId xmlns:a16="http://schemas.microsoft.com/office/drawing/2014/main" id="{F71A9957-90E1-EB11-EC51-1EDE47DA1E91}"/>
+                <a16:creationId xmlns:a16="http://schemas.microsoft.com/office/drawing/2014/main" id="{E18C394A-B460-EA9B-4962-EA95F91B533F}"/>
               </a:ext>
             </a:extLst>
           </p:cNvPr>
@@ -14246,7 +14246,7 @@
         </p:nvSpPr>
         <p:spPr>
           <a:xfrm>
-            <a:off x="11150691" y="8273038"/>
+            <a:off x="11150691" y="8479889"/>
             <a:ext cx="1416856" cy="466748"/>
           </a:xfrm>
           <a:prstGeom prst="rect">
@@ -14292,7 +14292,7 @@
           <p:cNvPr id="202" name="Google Shape;254;p18">
             <a:extLst>
               <a:ext uri="{FF2B5EF4-FFF2-40B4-BE49-F238E27FC236}">
-                <a16:creationId xmlns:a16="http://schemas.microsoft.com/office/drawing/2014/main" id="{90060BF0-DC66-87C3-4EFA-62D1581E27D1}"/>
+                <a16:creationId xmlns:a16="http://schemas.microsoft.com/office/drawing/2014/main" id="{C8DBA964-45DB-1964-6D75-4FC36E10F0D6}"/>
               </a:ext>
             </a:extLst>
           </p:cNvPr>
@@ -14301,7 +14301,7 @@
         </p:nvSpPr>
         <p:spPr>
           <a:xfrm>
-            <a:off x="12373642" y="8271673"/>
+            <a:off x="12373642" y="8478524"/>
             <a:ext cx="678035" cy="466748"/>
           </a:xfrm>
           <a:prstGeom prst="rect">
@@ -14347,7 +14347,7 @@
           <p:cNvPr id="203" name="Google Shape;255;p18">
             <a:extLst>
               <a:ext uri="{FF2B5EF4-FFF2-40B4-BE49-F238E27FC236}">
-                <a16:creationId xmlns:a16="http://schemas.microsoft.com/office/drawing/2014/main" id="{4C7E9DBD-D0B7-4F28-FBF6-BA6E9CD0364E}"/>
+                <a16:creationId xmlns:a16="http://schemas.microsoft.com/office/drawing/2014/main" id="{251C7ED0-2164-C94B-6409-FA8B3976E9E3}"/>
               </a:ext>
             </a:extLst>
           </p:cNvPr>
@@ -14356,7 +14356,7 @@
         </p:nvSpPr>
         <p:spPr>
           <a:xfrm>
-            <a:off x="13065618" y="8271359"/>
+            <a:off x="13065618" y="8478210"/>
             <a:ext cx="537849" cy="466748"/>
           </a:xfrm>
           <a:prstGeom prst="rect">
@@ -14402,7 +14402,7 @@
           <p:cNvPr id="204" name="Google Shape;292;p18">
             <a:extLst>
               <a:ext uri="{FF2B5EF4-FFF2-40B4-BE49-F238E27FC236}">
-                <a16:creationId xmlns:a16="http://schemas.microsoft.com/office/drawing/2014/main" id="{7F18E86C-D391-FFC1-3F36-616A8C696B39}"/>
+                <a16:creationId xmlns:a16="http://schemas.microsoft.com/office/drawing/2014/main" id="{323B7FF8-3511-E37C-F3C8-2539D091EDDC}"/>
               </a:ext>
             </a:extLst>
           </p:cNvPr>
@@ -14411,7 +14411,7 @@
         </p:nvSpPr>
         <p:spPr>
           <a:xfrm>
-            <a:off x="12833704" y="8369285"/>
+            <a:off x="12833704" y="8576136"/>
             <a:ext cx="246674" cy="249601"/>
           </a:xfrm>
           <a:prstGeom prst="ellipse">
@@ -14446,7 +14446,7 @@
           <p:cNvPr id="205" name="Google Shape;293;p18">
             <a:extLst>
               <a:ext uri="{FF2B5EF4-FFF2-40B4-BE49-F238E27FC236}">
-                <a16:creationId xmlns:a16="http://schemas.microsoft.com/office/drawing/2014/main" id="{6AF15C3A-17BA-5B6B-2BC7-1D5970EAA8A0}"/>
+                <a16:creationId xmlns:a16="http://schemas.microsoft.com/office/drawing/2014/main" id="{38C40302-5774-4646-F0A8-BDAA8AFC10A1}"/>
               </a:ext>
             </a:extLst>
           </p:cNvPr>
@@ -14455,7 +14455,7 @@
         </p:nvSpPr>
         <p:spPr>
           <a:xfrm>
-            <a:off x="12781309" y="8353731"/>
+            <a:off x="12781309" y="8560582"/>
             <a:ext cx="314386" cy="157250"/>
           </a:xfrm>
           <a:prstGeom prst="rect">
@@ -14495,7 +14495,7 @@
           <p:cNvPr id="206" name="Google Shape;292;p18">
             <a:extLst>
               <a:ext uri="{FF2B5EF4-FFF2-40B4-BE49-F238E27FC236}">
-                <a16:creationId xmlns:a16="http://schemas.microsoft.com/office/drawing/2014/main" id="{C6FD1A6B-7545-ABB6-529F-E45BBAD7F8C1}"/>
+                <a16:creationId xmlns:a16="http://schemas.microsoft.com/office/drawing/2014/main" id="{10394985-52F6-CD85-2A66-423FCDC88D04}"/>
               </a:ext>
             </a:extLst>
           </p:cNvPr>
@@ -14504,7 +14504,7 @@
         </p:nvSpPr>
         <p:spPr>
           <a:xfrm>
-            <a:off x="10691603" y="8500479"/>
+            <a:off x="10691603" y="8707330"/>
             <a:ext cx="246674" cy="249601"/>
           </a:xfrm>
           <a:prstGeom prst="ellipse">
@@ -14539,7 +14539,7 @@
           <p:cNvPr id="207" name="Google Shape;293;p18">
             <a:extLst>
               <a:ext uri="{FF2B5EF4-FFF2-40B4-BE49-F238E27FC236}">
-                <a16:creationId xmlns:a16="http://schemas.microsoft.com/office/drawing/2014/main" id="{E7648D42-CACF-C4DB-7226-8A475433793E}"/>
+                <a16:creationId xmlns:a16="http://schemas.microsoft.com/office/drawing/2014/main" id="{942DCA01-40B7-3620-79FE-4241CC7EB6F2}"/>
               </a:ext>
             </a:extLst>
           </p:cNvPr>
@@ -14548,7 +14548,7 @@
         </p:nvSpPr>
         <p:spPr>
           <a:xfrm>
-            <a:off x="10634578" y="8473214"/>
+            <a:off x="10634578" y="8680065"/>
             <a:ext cx="352254" cy="157250"/>
           </a:xfrm>
           <a:prstGeom prst="rect">
@@ -14588,7 +14588,7 @@
           <p:cNvPr id="208" name="Google Shape;292;p18">
             <a:extLst>
               <a:ext uri="{FF2B5EF4-FFF2-40B4-BE49-F238E27FC236}">
-                <a16:creationId xmlns:a16="http://schemas.microsoft.com/office/drawing/2014/main" id="{54068285-9754-DEFA-41A5-E24C34AEDDBA}"/>
+                <a16:creationId xmlns:a16="http://schemas.microsoft.com/office/drawing/2014/main" id="{D135E9E6-F54B-C46A-FAA1-53FCBC419120}"/>
               </a:ext>
             </a:extLst>
           </p:cNvPr>
@@ -14597,7 +14597,7 @@
         </p:nvSpPr>
         <p:spPr>
           <a:xfrm>
-            <a:off x="13510744" y="8364803"/>
+            <a:off x="13510744" y="8571654"/>
             <a:ext cx="246674" cy="249601"/>
           </a:xfrm>
           <a:prstGeom prst="ellipse">
@@ -14632,7 +14632,7 @@
           <p:cNvPr id="209" name="Google Shape;293;p18">
             <a:extLst>
               <a:ext uri="{FF2B5EF4-FFF2-40B4-BE49-F238E27FC236}">
-                <a16:creationId xmlns:a16="http://schemas.microsoft.com/office/drawing/2014/main" id="{8BFD3231-A6AF-BC40-CFBE-AC7F07D19EE2}"/>
+                <a16:creationId xmlns:a16="http://schemas.microsoft.com/office/drawing/2014/main" id="{5133E59B-BF43-694E-82E2-DB42703ED46A}"/>
               </a:ext>
             </a:extLst>
           </p:cNvPr>
@@ -14641,7 +14641,7 @@
         </p:nvSpPr>
         <p:spPr>
           <a:xfrm>
-            <a:off x="13425335" y="8343284"/>
+            <a:off x="13425335" y="8550135"/>
             <a:ext cx="422945" cy="157250"/>
           </a:xfrm>
           <a:prstGeom prst="rect">
@@ -14681,7 +14681,7 @@
           <p:cNvPr id="210" name="Google Shape;292;p18">
             <a:extLst>
               <a:ext uri="{FF2B5EF4-FFF2-40B4-BE49-F238E27FC236}">
-                <a16:creationId xmlns:a16="http://schemas.microsoft.com/office/drawing/2014/main" id="{15296570-63DD-2F08-260E-F0F3153DEE19}"/>
+                <a16:creationId xmlns:a16="http://schemas.microsoft.com/office/drawing/2014/main" id="{8D290042-9981-02A1-B343-24BE203C7F33}"/>
               </a:ext>
             </a:extLst>
           </p:cNvPr>
@@ -14690,7 +14690,7 @@
         </p:nvSpPr>
         <p:spPr>
           <a:xfrm>
-            <a:off x="10704703" y="8234739"/>
+            <a:off x="10704703" y="8441590"/>
             <a:ext cx="246674" cy="249601"/>
           </a:xfrm>
           <a:prstGeom prst="ellipse">
@@ -14725,7 +14725,7 @@
           <p:cNvPr id="211" name="Google Shape;293;p18">
             <a:extLst>
               <a:ext uri="{FF2B5EF4-FFF2-40B4-BE49-F238E27FC236}">
-                <a16:creationId xmlns:a16="http://schemas.microsoft.com/office/drawing/2014/main" id="{26EE57F3-0E8B-0404-8A99-DC3C03FBF4E7}"/>
+                <a16:creationId xmlns:a16="http://schemas.microsoft.com/office/drawing/2014/main" id="{3DBEB95B-7170-8120-16BA-03C32F114B8D}"/>
               </a:ext>
             </a:extLst>
           </p:cNvPr>
@@ -14734,7 +14734,7 @@
         </p:nvSpPr>
         <p:spPr>
           <a:xfrm>
-            <a:off x="10650080" y="8207729"/>
+            <a:off x="10650080" y="8414580"/>
             <a:ext cx="359792" cy="157250"/>
           </a:xfrm>
           <a:prstGeom prst="rect">
@@ -14774,7 +14774,7 @@
           <p:cNvPr id="218" name="Google Shape;320;p18">
             <a:extLst>
               <a:ext uri="{FF2B5EF4-FFF2-40B4-BE49-F238E27FC236}">
-                <a16:creationId xmlns:a16="http://schemas.microsoft.com/office/drawing/2014/main" id="{870BD0AD-9EDF-20AB-725A-F3FFF92C1982}"/>
+                <a16:creationId xmlns:a16="http://schemas.microsoft.com/office/drawing/2014/main" id="{778A14E5-F7A4-2CCB-4740-69652C04CA4C}"/>
               </a:ext>
             </a:extLst>
           </p:cNvPr>
@@ -14783,7 +14783,7 @@
         </p:nvSpPr>
         <p:spPr>
           <a:xfrm>
-            <a:off x="11654473" y="9220001"/>
+            <a:off x="11654473" y="9426852"/>
             <a:ext cx="109507" cy="116681"/>
           </a:xfrm>
           <a:prstGeom prst="rect">
@@ -14822,7 +14822,7 @@
           <p:cNvPr id="252" name="Google Shape;292;p18">
             <a:extLst>
               <a:ext uri="{FF2B5EF4-FFF2-40B4-BE49-F238E27FC236}">
-                <a16:creationId xmlns:a16="http://schemas.microsoft.com/office/drawing/2014/main" id="{DA7142BC-4419-C6EA-176D-5DC91174CC41}"/>
+                <a16:creationId xmlns:a16="http://schemas.microsoft.com/office/drawing/2014/main" id="{CACC4622-7F3D-025D-1179-2A56664B0286}"/>
               </a:ext>
             </a:extLst>
           </p:cNvPr>
@@ -14831,7 +14831,7 @@
         </p:nvSpPr>
         <p:spPr>
           <a:xfrm>
-            <a:off x="10947364" y="8514400"/>
+            <a:off x="10947364" y="8721251"/>
             <a:ext cx="246674" cy="249601"/>
           </a:xfrm>
           <a:prstGeom prst="ellipse">
@@ -14866,7 +14866,7 @@
           <p:cNvPr id="256" name="Google Shape;293;p18">
             <a:extLst>
               <a:ext uri="{FF2B5EF4-FFF2-40B4-BE49-F238E27FC236}">
-                <a16:creationId xmlns:a16="http://schemas.microsoft.com/office/drawing/2014/main" id="{37646487-1E0F-A3D0-38E7-3012E7999E78}"/>
+                <a16:creationId xmlns:a16="http://schemas.microsoft.com/office/drawing/2014/main" id="{0CAEFEC6-38F5-4AD0-E00F-92FE7A68F2BB}"/>
               </a:ext>
             </a:extLst>
           </p:cNvPr>
@@ -14875,7 +14875,7 @@
         </p:nvSpPr>
         <p:spPr>
           <a:xfrm>
-            <a:off x="10861764" y="8483960"/>
+            <a:off x="10861764" y="8690811"/>
             <a:ext cx="441140" cy="157250"/>
           </a:xfrm>
           <a:prstGeom prst="rect">
@@ -14915,7 +14915,7 @@
           <p:cNvPr id="257" name="Google Shape;232;p18">
             <a:extLst>
               <a:ext uri="{FF2B5EF4-FFF2-40B4-BE49-F238E27FC236}">
-                <a16:creationId xmlns:a16="http://schemas.microsoft.com/office/drawing/2014/main" id="{DC624640-AF03-4FFE-255C-993FCFFFD92C}"/>
+                <a16:creationId xmlns:a16="http://schemas.microsoft.com/office/drawing/2014/main" id="{A943BD4B-F46C-F990-C744-D46BE033E5CF}"/>
               </a:ext>
             </a:extLst>
           </p:cNvPr>
@@ -14924,7 +14924,7 @@
         </p:nvSpPr>
         <p:spPr>
           <a:xfrm>
-            <a:off x="9397411" y="5097112"/>
+            <a:off x="9397411" y="5303963"/>
             <a:ext cx="4467375" cy="1205412"/>
           </a:xfrm>
           <a:prstGeom prst="rect">
@@ -15082,7 +15082,7 @@
           <p:cNvPr id="20" name="Picture 19" descr="A picture containing text&#10;&#10;Description automatically generated">
             <a:extLst>
               <a:ext uri="{FF2B5EF4-FFF2-40B4-BE49-F238E27FC236}">
-                <a16:creationId xmlns:a16="http://schemas.microsoft.com/office/drawing/2014/main" id="{DDE7FACE-3CD8-47F8-0E32-8514F50923CA}"/>
+                <a16:creationId xmlns:a16="http://schemas.microsoft.com/office/drawing/2014/main" id="{EAB0A844-D66C-4F8C-5FCA-2B0A2BED32C8}"/>
               </a:ext>
             </a:extLst>
           </p:cNvPr>
@@ -15105,7 +15105,7 @@
         </p:blipFill>
         <p:spPr>
           <a:xfrm>
-            <a:off x="5628071" y="4867299"/>
+            <a:off x="5628071" y="5074150"/>
             <a:ext cx="423964" cy="492345"/>
           </a:xfrm>
           <a:prstGeom prst="rect">
@@ -15113,10 +15113,202 @@
           </a:prstGeom>
         </p:spPr>
       </p:pic>
+      <p:sp>
+        <p:nvSpPr>
+          <p:cNvPr id="5" name="Line">
+            <a:extLst>
+              <a:ext uri="{FF2B5EF4-FFF2-40B4-BE49-F238E27FC236}">
+                <a16:creationId xmlns:a16="http://schemas.microsoft.com/office/drawing/2014/main" id="{5DF8A8BB-A29C-1CF4-5015-957D3F87E65A}"/>
+              </a:ext>
+            </a:extLst>
+          </p:cNvPr>
+          <p:cNvSpPr/>
+          <p:nvPr/>
+        </p:nvSpPr>
+        <p:spPr>
+          <a:xfrm flipV="1">
+            <a:off x="411063" y="1826396"/>
+            <a:ext cx="3269397" cy="0"/>
+          </a:xfrm>
+          <a:prstGeom prst="line">
+            <a:avLst/>
+          </a:prstGeom>
+          <a:ln w="12700">
+            <a:solidFill>
+              <a:srgbClr val="E4E4E3"/>
+            </a:solidFill>
+            <a:miter lim="400000"/>
+          </a:ln>
+        </p:spPr>
+        <p:txBody>
+          <a:bodyPr lIns="54570" tIns="54570" rIns="54570" bIns="54570" anchor="ctr"/>
+          <a:lstStyle/>
+          <a:p>
+            <a:pPr>
+              <a:lnSpc>
+                <a:spcPct val="80000"/>
+              </a:lnSpc>
+              <a:spcBef>
+                <a:spcPts val="600"/>
+              </a:spcBef>
+              <a:defRPr b="0">
+                <a:solidFill>
+                  <a:srgbClr val="000000"/>
+                </a:solidFill>
+              </a:defRPr>
+            </a:pPr>
+            <a:endParaRPr/>
+          </a:p>
+        </p:txBody>
+      </p:sp>
+      <p:sp>
+        <p:nvSpPr>
+          <p:cNvPr id="7" name="Line">
+            <a:extLst>
+              <a:ext uri="{FF2B5EF4-FFF2-40B4-BE49-F238E27FC236}">
+                <a16:creationId xmlns:a16="http://schemas.microsoft.com/office/drawing/2014/main" id="{2726B145-741C-BB5A-81D1-26B87B46A0CE}"/>
+              </a:ext>
+            </a:extLst>
+          </p:cNvPr>
+          <p:cNvSpPr/>
+          <p:nvPr/>
+        </p:nvSpPr>
+        <p:spPr>
+          <a:xfrm flipV="1">
+            <a:off x="4467992" y="1826396"/>
+            <a:ext cx="3273552" cy="0"/>
+          </a:xfrm>
+          <a:prstGeom prst="line">
+            <a:avLst/>
+          </a:prstGeom>
+          <a:ln w="12700">
+            <a:solidFill>
+              <a:srgbClr val="E4E4E3"/>
+            </a:solidFill>
+            <a:miter lim="400000"/>
+          </a:ln>
+        </p:spPr>
+        <p:txBody>
+          <a:bodyPr lIns="54570" tIns="54570" rIns="54570" bIns="54570" anchor="ctr"/>
+          <a:lstStyle/>
+          <a:p>
+            <a:pPr>
+              <a:lnSpc>
+                <a:spcPct val="80000"/>
+              </a:lnSpc>
+              <a:spcBef>
+                <a:spcPts val="600"/>
+              </a:spcBef>
+              <a:defRPr b="0">
+                <a:solidFill>
+                  <a:srgbClr val="000000"/>
+                </a:solidFill>
+              </a:defRPr>
+            </a:pPr>
+            <a:endParaRPr/>
+          </a:p>
+        </p:txBody>
+      </p:sp>
+      <p:sp>
+        <p:nvSpPr>
+          <p:cNvPr id="9" name="Line">
+            <a:extLst>
+              <a:ext uri="{FF2B5EF4-FFF2-40B4-BE49-F238E27FC236}">
+                <a16:creationId xmlns:a16="http://schemas.microsoft.com/office/drawing/2014/main" id="{76BA2772-7DE8-965D-EEB9-953AB9C37F89}"/>
+              </a:ext>
+            </a:extLst>
+          </p:cNvPr>
+          <p:cNvSpPr/>
+          <p:nvPr/>
+        </p:nvSpPr>
+        <p:spPr>
+          <a:xfrm>
+            <a:off x="9474332" y="1825338"/>
+            <a:ext cx="3273552" cy="1057"/>
+          </a:xfrm>
+          <a:prstGeom prst="line">
+            <a:avLst/>
+          </a:prstGeom>
+          <a:ln w="12700">
+            <a:solidFill>
+              <a:srgbClr val="E4E4E3"/>
+            </a:solidFill>
+            <a:miter lim="400000"/>
+          </a:ln>
+        </p:spPr>
+        <p:txBody>
+          <a:bodyPr lIns="54570" tIns="54570" rIns="54570" bIns="54570" anchor="ctr"/>
+          <a:lstStyle/>
+          <a:p>
+            <a:pPr>
+              <a:lnSpc>
+                <a:spcPct val="80000"/>
+              </a:lnSpc>
+              <a:spcBef>
+                <a:spcPts val="600"/>
+              </a:spcBef>
+              <a:defRPr b="0">
+                <a:solidFill>
+                  <a:srgbClr val="000000"/>
+                </a:solidFill>
+              </a:defRPr>
+            </a:pPr>
+            <a:endParaRPr/>
+          </a:p>
+        </p:txBody>
+      </p:sp>
+      <p:sp>
+        <p:nvSpPr>
+          <p:cNvPr id="19" name="Line">
+            <a:extLst>
+              <a:ext uri="{FF2B5EF4-FFF2-40B4-BE49-F238E27FC236}">
+                <a16:creationId xmlns:a16="http://schemas.microsoft.com/office/drawing/2014/main" id="{E8700110-A7F4-6B34-5CCA-3319B01FC8A9}"/>
+              </a:ext>
+            </a:extLst>
+          </p:cNvPr>
+          <p:cNvSpPr/>
+          <p:nvPr/>
+        </p:nvSpPr>
+        <p:spPr>
+          <a:xfrm>
+            <a:off x="9474332" y="4275552"/>
+            <a:ext cx="3273552" cy="1057"/>
+          </a:xfrm>
+          <a:prstGeom prst="line">
+            <a:avLst/>
+          </a:prstGeom>
+          <a:ln w="12700">
+            <a:solidFill>
+              <a:srgbClr val="E4E4E3"/>
+            </a:solidFill>
+            <a:miter lim="400000"/>
+          </a:ln>
+        </p:spPr>
+        <p:txBody>
+          <a:bodyPr lIns="54570" tIns="54570" rIns="54570" bIns="54570" anchor="ctr"/>
+          <a:lstStyle/>
+          <a:p>
+            <a:pPr>
+              <a:lnSpc>
+                <a:spcPct val="80000"/>
+              </a:lnSpc>
+              <a:spcBef>
+                <a:spcPts val="600"/>
+              </a:spcBef>
+              <a:defRPr b="0">
+                <a:solidFill>
+                  <a:srgbClr val="000000"/>
+                </a:solidFill>
+              </a:defRPr>
+            </a:pPr>
+            <a:endParaRPr/>
+          </a:p>
+        </p:txBody>
+      </p:sp>
     </p:spTree>
     <p:extLst>
       <p:ext uri="{BB962C8B-B14F-4D97-AF65-F5344CB8AC3E}">
-        <p14:creationId xmlns:p14="http://schemas.microsoft.com/office/powerpoint/2010/main" val="2609457707"/>
+        <p14:creationId xmlns:p14="http://schemas.microsoft.com/office/powerpoint/2010/main" val="600062408"/>
       </p:ext>
     </p:extLst>
   </p:cSld>

</xml_diff>